<commit_message>
docs: finalize all deliverables — add ER diagram, test results, fix inconsistencies
- Add Links section to technical report (13 items covering all deliverables)
- Add ER diagram (Navicat) with N:N relationship annotations
- Add Testing Strategy, Data Source, and References sections to report
- Add test-results.txt (28 passed against PythonAnywhere)
- Add VCS + Deliverables slides to presentation (now 11 slides)
- Fix README: tool count 15→16, bcrypt version 4.0.1→4.2.1
- Fix .env.example: aiosqlite→sqlite driver
- Fix pyproject.toml: remove stale async dependencies
- Add GET / root endpoint and curl example to API docs
- Add ~$* to .gitignore for Office temp files
- Remove presentation.md (replaced by PPTX)
</commit_message>
<xml_diff>
--- a/docs/presentation.pptx
+++ b/docs/presentation.pptx
@@ -5,16 +5,19 @@
     <p:sldMasterId id="2147483648" r:id="rId1"/>
   </p:sldMasterIdLst>
   <p:notesMasterIdLst>
-    <p:notesMasterId r:id="rId9"/>
+    <p:notesMasterId r:id="rId12"/>
   </p:notesMasterIdLst>
   <p:sldIdLst>
     <p:sldId id="256" r:id="rId2"/>
     <p:sldId id="257" r:id="rId3"/>
     <p:sldId id="258" r:id="rId4"/>
     <p:sldId id="259" r:id="rId5"/>
-    <p:sldId id="260" r:id="rId6"/>
-    <p:sldId id="261" r:id="rId7"/>
-    <p:sldId id="262" r:id="rId8"/>
+    <p:sldId id="267" r:id="rId6"/>
+    <p:sldId id="260" r:id="rId7"/>
+    <p:sldId id="261" r:id="rId8"/>
+    <p:sldId id="265" r:id="rId9"/>
+    <p:sldId id="266" r:id="rId10"/>
+    <p:sldId id="262" r:id="rId11"/>
   </p:sldIdLst>
   <p:sldSz cx="9144000" cy="5143500" type="screen16x9"/>
   <p:notesSz cx="5143500" cy="9144000"/>
@@ -327,6 +330,90 @@
 </p:notes>
 </file>
 
+<file path=ppt/notesSlides/notesSlide10.xml><?xml version="1.0" encoding="utf-8"?>
+<p:notes xmlns:a="http://schemas.openxmlformats.org/drawingml/2006/main" xmlns:r="http://schemas.openxmlformats.org/officeDocument/2006/relationships" xmlns:p="http://schemas.openxmlformats.org/presentationml/2006/main">
+  <p:cSld>
+    <p:spTree>
+      <p:nvGrpSpPr>
+        <p:cNvPr id="1" name=""/>
+        <p:cNvGrpSpPr/>
+        <p:nvPr/>
+      </p:nvGrpSpPr>
+      <p:grpSpPr>
+        <a:xfrm>
+          <a:off x="0" y="0"/>
+          <a:ext cx="0" cy="0"/>
+          <a:chOff x="0" y="0"/>
+          <a:chExt cx="0" cy="0"/>
+        </a:xfrm>
+      </p:grpSpPr>
+      <p:sp>
+        <p:nvSpPr>
+          <p:cNvPr id="2" name="Slide Image Placeholder 1"/>
+          <p:cNvSpPr>
+            <a:spLocks noGrp="1" noRot="1" noChangeAspect="1"/>
+          </p:cNvSpPr>
+          <p:nvPr>
+            <p:ph type="sldImg"/>
+          </p:nvPr>
+        </p:nvSpPr>
+        <p:spPr/>
+      </p:sp>
+      <p:sp>
+        <p:nvSpPr>
+          <p:cNvPr id="3" name="Notes Placeholder 2"/>
+          <p:cNvSpPr>
+            <a:spLocks noGrp="1"/>
+          </p:cNvSpPr>
+          <p:nvPr>
+            <p:ph type="body" idx="1"/>
+          </p:nvPr>
+        </p:nvSpPr>
+        <p:spPr/>
+        <p:txBody>
+          <a:bodyPr/>
+          <a:lstStyle/>
+          <a:p>
+            <a:endParaRPr lang="en-US" dirty="0"/>
+          </a:p>
+        </p:txBody>
+      </p:sp>
+      <p:sp>
+        <p:nvSpPr>
+          <p:cNvPr id="4" name="Slide Number Placeholder 3"/>
+          <p:cNvSpPr>
+            <a:spLocks noGrp="1"/>
+          </p:cNvSpPr>
+          <p:nvPr>
+            <p:ph type="sldNum" sz="quarter" idx="10"/>
+          </p:nvPr>
+        </p:nvSpPr>
+        <p:spPr/>
+        <p:txBody>
+          <a:bodyPr/>
+          <a:lstStyle/>
+          <a:p>
+            <a:fld id="{F7021451-1387-4CA6-816F-3879F97B5CBC}" type="slidenum">
+              <a:rPr lang="en-US"/>
+              <a:t>10</a:t>
+            </a:fld>
+            <a:endParaRPr lang="en-US"/>
+          </a:p>
+        </p:txBody>
+      </p:sp>
+    </p:spTree>
+    <p:extLst>
+      <p:ext uri="{BB962C8B-B14F-4D97-AF65-F5344CB8AC3E}">
+        <p14:creationId xmlns:p14="http://schemas.microsoft.com/office/powerpoint/2010/main" val="1024086991"/>
+      </p:ext>
+    </p:extLst>
+  </p:cSld>
+  <p:clrMapOvr>
+    <a:masterClrMapping/>
+  </p:clrMapOvr>
+</p:notes>
+</file>
+
 <file path=ppt/notesSlides/notesSlide2.xml><?xml version="1.0" encoding="utf-8"?>
 <p:notes xmlns:a="http://schemas.openxmlformats.org/drawingml/2006/main" xmlns:r="http://schemas.openxmlformats.org/officeDocument/2006/relationships" xmlns:p="http://schemas.openxmlformats.org/presentationml/2006/main">
   <p:cSld>
@@ -584,7 +671,13 @@
   <p:cSld>
     <p:spTree>
       <p:nvGrpSpPr>
-        <p:cNvPr id="1" name=""/>
+        <p:cNvPr id="1" name="">
+          <a:extLst>
+            <a:ext uri="{FF2B5EF4-FFF2-40B4-BE49-F238E27FC236}">
+              <a16:creationId xmlns:a16="http://schemas.microsoft.com/office/drawing/2014/main" id="{4D78A258-BE1A-081A-465F-E3BA2719AC5C}"/>
+            </a:ext>
+          </a:extLst>
+        </p:cNvPr>
         <p:cNvGrpSpPr/>
         <p:nvPr/>
       </p:nvGrpSpPr>
@@ -598,7 +691,13 @@
       </p:grpSpPr>
       <p:sp>
         <p:nvSpPr>
-          <p:cNvPr id="2" name="Slide Image Placeholder 1"/>
+          <p:cNvPr id="2" name="Slide Image Placeholder 1">
+            <a:extLst>
+              <a:ext uri="{FF2B5EF4-FFF2-40B4-BE49-F238E27FC236}">
+                <a16:creationId xmlns:a16="http://schemas.microsoft.com/office/drawing/2014/main" id="{A5A805D7-C569-F7C5-B2B4-951115F67FAE}"/>
+              </a:ext>
+            </a:extLst>
+          </p:cNvPr>
           <p:cNvSpPr>
             <a:spLocks noGrp="1" noRot="1" noChangeAspect="1"/>
           </p:cNvSpPr>
@@ -610,7 +709,13 @@
       </p:sp>
       <p:sp>
         <p:nvSpPr>
-          <p:cNvPr id="3" name="Notes Placeholder 2"/>
+          <p:cNvPr id="3" name="Notes Placeholder 2">
+            <a:extLst>
+              <a:ext uri="{FF2B5EF4-FFF2-40B4-BE49-F238E27FC236}">
+                <a16:creationId xmlns:a16="http://schemas.microsoft.com/office/drawing/2014/main" id="{7DDE81EA-B527-5B28-45EE-69FE9DD4F060}"/>
+              </a:ext>
+            </a:extLst>
+          </p:cNvPr>
           <p:cNvSpPr>
             <a:spLocks noGrp="1"/>
           </p:cNvSpPr>
@@ -629,7 +734,13 @@
       </p:sp>
       <p:sp>
         <p:nvSpPr>
-          <p:cNvPr id="4" name="Slide Number Placeholder 3"/>
+          <p:cNvPr id="4" name="Slide Number Placeholder 3">
+            <a:extLst>
+              <a:ext uri="{FF2B5EF4-FFF2-40B4-BE49-F238E27FC236}">
+                <a16:creationId xmlns:a16="http://schemas.microsoft.com/office/drawing/2014/main" id="{04CD7343-D4D5-28AE-9593-5900E3463C89}"/>
+              </a:ext>
+            </a:extLst>
+          </p:cNvPr>
           <p:cNvSpPr>
             <a:spLocks noGrp="1"/>
           </p:cNvSpPr>
@@ -653,7 +764,7 @@
     </p:spTree>
     <p:extLst>
       <p:ext uri="{BB962C8B-B14F-4D97-AF65-F5344CB8AC3E}">
-        <p14:creationId xmlns:p14="http://schemas.microsoft.com/office/powerpoint/2010/main" val="1024086991"/>
+        <p14:creationId xmlns:p14="http://schemas.microsoft.com/office/powerpoint/2010/main" val="3978187354"/>
       </p:ext>
     </p:extLst>
   </p:cSld>
@@ -822,6 +933,222 @@
     <p:extLst>
       <p:ext uri="{BB962C8B-B14F-4D97-AF65-F5344CB8AC3E}">
         <p14:creationId xmlns:p14="http://schemas.microsoft.com/office/powerpoint/2010/main" val="1024086991"/>
+      </p:ext>
+    </p:extLst>
+  </p:cSld>
+  <p:clrMapOvr>
+    <a:masterClrMapping/>
+  </p:clrMapOvr>
+</p:notes>
+</file>
+
+<file path=ppt/notesSlides/notesSlide8.xml><?xml version="1.0" encoding="utf-8"?>
+<p:notes xmlns:a="http://schemas.openxmlformats.org/drawingml/2006/main" xmlns:r="http://schemas.openxmlformats.org/officeDocument/2006/relationships" xmlns:p="http://schemas.openxmlformats.org/presentationml/2006/main">
+  <p:cSld>
+    <p:spTree>
+      <p:nvGrpSpPr>
+        <p:cNvPr id="1" name="">
+          <a:extLst>
+            <a:ext uri="{FF2B5EF4-FFF2-40B4-BE49-F238E27FC236}">
+              <a16:creationId xmlns:a16="http://schemas.microsoft.com/office/drawing/2014/main" id="{16645287-741E-391E-7E06-831A5E49A232}"/>
+            </a:ext>
+          </a:extLst>
+        </p:cNvPr>
+        <p:cNvGrpSpPr/>
+        <p:nvPr/>
+      </p:nvGrpSpPr>
+      <p:grpSpPr>
+        <a:xfrm>
+          <a:off x="0" y="0"/>
+          <a:ext cx="0" cy="0"/>
+          <a:chOff x="0" y="0"/>
+          <a:chExt cx="0" cy="0"/>
+        </a:xfrm>
+      </p:grpSpPr>
+      <p:sp>
+        <p:nvSpPr>
+          <p:cNvPr id="2" name="Slide Image Placeholder 1">
+            <a:extLst>
+              <a:ext uri="{FF2B5EF4-FFF2-40B4-BE49-F238E27FC236}">
+                <a16:creationId xmlns:a16="http://schemas.microsoft.com/office/drawing/2014/main" id="{43E01622-548D-AC8C-015F-BB1CB37F9F19}"/>
+              </a:ext>
+            </a:extLst>
+          </p:cNvPr>
+          <p:cNvSpPr>
+            <a:spLocks noGrp="1" noRot="1" noChangeAspect="1"/>
+          </p:cNvSpPr>
+          <p:nvPr>
+            <p:ph type="sldImg"/>
+          </p:nvPr>
+        </p:nvSpPr>
+        <p:spPr/>
+      </p:sp>
+      <p:sp>
+        <p:nvSpPr>
+          <p:cNvPr id="3" name="Notes Placeholder 2">
+            <a:extLst>
+              <a:ext uri="{FF2B5EF4-FFF2-40B4-BE49-F238E27FC236}">
+                <a16:creationId xmlns:a16="http://schemas.microsoft.com/office/drawing/2014/main" id="{D64B1185-09A2-9237-56E9-BF1B858D47A1}"/>
+              </a:ext>
+            </a:extLst>
+          </p:cNvPr>
+          <p:cNvSpPr>
+            <a:spLocks noGrp="1"/>
+          </p:cNvSpPr>
+          <p:nvPr>
+            <p:ph type="body" idx="1"/>
+          </p:nvPr>
+        </p:nvSpPr>
+        <p:spPr/>
+        <p:txBody>
+          <a:bodyPr/>
+          <a:lstStyle/>
+          <a:p>
+            <a:endParaRPr lang="en-US" dirty="0"/>
+          </a:p>
+        </p:txBody>
+      </p:sp>
+      <p:sp>
+        <p:nvSpPr>
+          <p:cNvPr id="4" name="Slide Number Placeholder 3">
+            <a:extLst>
+              <a:ext uri="{FF2B5EF4-FFF2-40B4-BE49-F238E27FC236}">
+                <a16:creationId xmlns:a16="http://schemas.microsoft.com/office/drawing/2014/main" id="{7FCF6F39-D795-0A2D-C07F-365DDACBC090}"/>
+              </a:ext>
+            </a:extLst>
+          </p:cNvPr>
+          <p:cNvSpPr>
+            <a:spLocks noGrp="1"/>
+          </p:cNvSpPr>
+          <p:nvPr>
+            <p:ph type="sldNum" sz="quarter" idx="10"/>
+          </p:nvPr>
+        </p:nvSpPr>
+        <p:spPr/>
+        <p:txBody>
+          <a:bodyPr/>
+          <a:lstStyle/>
+          <a:p>
+            <a:fld id="{F7021451-1387-4CA6-816F-3879F97B5CBC}" type="slidenum">
+              <a:rPr lang="en-US"/>
+              <a:t>8</a:t>
+            </a:fld>
+            <a:endParaRPr lang="en-US"/>
+          </a:p>
+        </p:txBody>
+      </p:sp>
+    </p:spTree>
+    <p:extLst>
+      <p:ext uri="{BB962C8B-B14F-4D97-AF65-F5344CB8AC3E}">
+        <p14:creationId xmlns:p14="http://schemas.microsoft.com/office/powerpoint/2010/main" val="3237994274"/>
+      </p:ext>
+    </p:extLst>
+  </p:cSld>
+  <p:clrMapOvr>
+    <a:masterClrMapping/>
+  </p:clrMapOvr>
+</p:notes>
+</file>
+
+<file path=ppt/notesSlides/notesSlide9.xml><?xml version="1.0" encoding="utf-8"?>
+<p:notes xmlns:a="http://schemas.openxmlformats.org/drawingml/2006/main" xmlns:r="http://schemas.openxmlformats.org/officeDocument/2006/relationships" xmlns:p="http://schemas.openxmlformats.org/presentationml/2006/main">
+  <p:cSld>
+    <p:spTree>
+      <p:nvGrpSpPr>
+        <p:cNvPr id="1" name="">
+          <a:extLst>
+            <a:ext uri="{FF2B5EF4-FFF2-40B4-BE49-F238E27FC236}">
+              <a16:creationId xmlns:a16="http://schemas.microsoft.com/office/drawing/2014/main" id="{7A46D18F-E44A-3DF6-3C33-3F8ABA7DA6A4}"/>
+            </a:ext>
+          </a:extLst>
+        </p:cNvPr>
+        <p:cNvGrpSpPr/>
+        <p:nvPr/>
+      </p:nvGrpSpPr>
+      <p:grpSpPr>
+        <a:xfrm>
+          <a:off x="0" y="0"/>
+          <a:ext cx="0" cy="0"/>
+          <a:chOff x="0" y="0"/>
+          <a:chExt cx="0" cy="0"/>
+        </a:xfrm>
+      </p:grpSpPr>
+      <p:sp>
+        <p:nvSpPr>
+          <p:cNvPr id="2" name="Slide Image Placeholder 1">
+            <a:extLst>
+              <a:ext uri="{FF2B5EF4-FFF2-40B4-BE49-F238E27FC236}">
+                <a16:creationId xmlns:a16="http://schemas.microsoft.com/office/drawing/2014/main" id="{4A450BFF-7E0C-9B15-E4B8-5BEB8D0A630C}"/>
+              </a:ext>
+            </a:extLst>
+          </p:cNvPr>
+          <p:cNvSpPr>
+            <a:spLocks noGrp="1" noRot="1" noChangeAspect="1"/>
+          </p:cNvSpPr>
+          <p:nvPr>
+            <p:ph type="sldImg"/>
+          </p:nvPr>
+        </p:nvSpPr>
+        <p:spPr/>
+      </p:sp>
+      <p:sp>
+        <p:nvSpPr>
+          <p:cNvPr id="3" name="Notes Placeholder 2">
+            <a:extLst>
+              <a:ext uri="{FF2B5EF4-FFF2-40B4-BE49-F238E27FC236}">
+                <a16:creationId xmlns:a16="http://schemas.microsoft.com/office/drawing/2014/main" id="{9D6EAC2A-DC49-E48A-8032-65722BF8EAFD}"/>
+              </a:ext>
+            </a:extLst>
+          </p:cNvPr>
+          <p:cNvSpPr>
+            <a:spLocks noGrp="1"/>
+          </p:cNvSpPr>
+          <p:nvPr>
+            <p:ph type="body" idx="1"/>
+          </p:nvPr>
+        </p:nvSpPr>
+        <p:spPr/>
+        <p:txBody>
+          <a:bodyPr/>
+          <a:lstStyle/>
+          <a:p>
+            <a:endParaRPr lang="en-US" dirty="0"/>
+          </a:p>
+        </p:txBody>
+      </p:sp>
+      <p:sp>
+        <p:nvSpPr>
+          <p:cNvPr id="4" name="Slide Number Placeholder 3">
+            <a:extLst>
+              <a:ext uri="{FF2B5EF4-FFF2-40B4-BE49-F238E27FC236}">
+                <a16:creationId xmlns:a16="http://schemas.microsoft.com/office/drawing/2014/main" id="{0CE343DE-E186-5523-EFCB-370CD3C10391}"/>
+              </a:ext>
+            </a:extLst>
+          </p:cNvPr>
+          <p:cNvSpPr>
+            <a:spLocks noGrp="1"/>
+          </p:cNvSpPr>
+          <p:nvPr>
+            <p:ph type="sldNum" sz="quarter" idx="10"/>
+          </p:nvPr>
+        </p:nvSpPr>
+        <p:spPr/>
+        <p:txBody>
+          <a:bodyPr/>
+          <a:lstStyle/>
+          <a:p>
+            <a:fld id="{F7021451-1387-4CA6-816F-3879F97B5CBC}" type="slidenum">
+              <a:rPr lang="en-US"/>
+              <a:t>9</a:t>
+            </a:fld>
+            <a:endParaRPr lang="en-US"/>
+          </a:p>
+        </p:txBody>
+      </p:sp>
+    </p:spTree>
+    <p:extLst>
+      <p:ext uri="{BB962C8B-B14F-4D97-AF65-F5344CB8AC3E}">
+        <p14:creationId xmlns:p14="http://schemas.microsoft.com/office/powerpoint/2010/main" val="153388880"/>
       </p:ext>
     </p:extLst>
   </p:cSld>
@@ -1391,6 +1718,335 @@
               <a:t>Live: https://lichenxi.pythonanywhere.com</a:t>
             </a:r>
             <a:endParaRPr lang="en-US" sz="1300" dirty="0"/>
+          </a:p>
+        </p:txBody>
+      </p:sp>
+    </p:spTree>
+  </p:cSld>
+  <p:clrMapOvr>
+    <a:masterClrMapping/>
+  </p:clrMapOvr>
+</p:sld>
+</file>
+
+<file path=ppt/slides/slide10.xml><?xml version="1.0" encoding="utf-8"?>
+<p:sld xmlns:a="http://schemas.openxmlformats.org/drawingml/2006/main" xmlns:r="http://schemas.openxmlformats.org/officeDocument/2006/relationships" xmlns:p="http://schemas.openxmlformats.org/presentationml/2006/main">
+  <p:cSld name="Slide 7">
+    <p:bg>
+      <p:bgPr>
+        <a:solidFill>
+          <a:srgbClr val="1F4E79"/>
+        </a:solidFill>
+        <a:effectLst/>
+      </p:bgPr>
+    </p:bg>
+    <p:spTree>
+      <p:nvGrpSpPr>
+        <p:cNvPr id="1" name=""/>
+        <p:cNvGrpSpPr/>
+        <p:nvPr/>
+      </p:nvGrpSpPr>
+      <p:grpSpPr>
+        <a:xfrm>
+          <a:off x="0" y="0"/>
+          <a:ext cx="0" cy="0"/>
+          <a:chOff x="0" y="0"/>
+          <a:chExt cx="0" cy="0"/>
+        </a:xfrm>
+      </p:grpSpPr>
+      <p:sp>
+        <p:nvSpPr>
+          <p:cNvPr id="2" name="Text 0"/>
+          <p:cNvSpPr/>
+          <p:nvPr/>
+        </p:nvSpPr>
+        <p:spPr>
+          <a:xfrm>
+            <a:off x="457200" y="182880"/>
+            <a:ext cx="8229600" cy="365760"/>
+          </a:xfrm>
+          <a:prstGeom prst="rect">
+            <a:avLst/>
+          </a:prstGeom>
+          <a:noFill/>
+          <a:ln/>
+        </p:spPr>
+        <p:txBody>
+          <a:bodyPr wrap="square" rtlCol="0" anchor="ctr"/>
+          <a:lstStyle/>
+          <a:p>
+            <a:pPr marL="0" indent="0">
+              <a:buNone/>
+            </a:pPr>
+            <a:r>
+              <a:rPr lang="en-US" sz="2000" dirty="0">
+                <a:solidFill>
+                  <a:srgbClr val="A0BBDD"/>
+                </a:solidFill>
+                <a:latin typeface="Arial" pitchFamily="34" charset="0"/>
+                <a:ea typeface="Arial" pitchFamily="34" charset="-122"/>
+                <a:cs typeface="Arial" pitchFamily="34" charset="-120"/>
+              </a:rPr>
+              <a:t>Technical Report Summary &amp; Conclusions</a:t>
+            </a:r>
+            <a:endParaRPr lang="en-US" sz="2000" dirty="0"/>
+          </a:p>
+        </p:txBody>
+      </p:sp>
+      <p:sp>
+        <p:nvSpPr>
+          <p:cNvPr id="3" name="Shape 1"/>
+          <p:cNvSpPr/>
+          <p:nvPr/>
+        </p:nvSpPr>
+        <p:spPr>
+          <a:xfrm>
+            <a:off x="457200" y="548640"/>
+            <a:ext cx="8229600" cy="36576"/>
+          </a:xfrm>
+          <a:prstGeom prst="rect">
+            <a:avLst/>
+          </a:prstGeom>
+          <a:solidFill>
+            <a:srgbClr val="2E75B6"/>
+          </a:solidFill>
+          <a:ln/>
+        </p:spPr>
+        <p:txBody>
+          <a:bodyPr/>
+          <a:lstStyle/>
+          <a:p>
+            <a:endParaRPr lang="zh-CN" altLang="en-US"/>
+          </a:p>
+        </p:txBody>
+      </p:sp>
+      <p:sp>
+        <p:nvSpPr>
+          <p:cNvPr id="4" name="Text 2"/>
+          <p:cNvSpPr/>
+          <p:nvPr/>
+        </p:nvSpPr>
+        <p:spPr>
+          <a:xfrm>
+            <a:off x="457200" y="822960"/>
+            <a:ext cx="8229600" cy="3108960"/>
+          </a:xfrm>
+          <a:prstGeom prst="rect">
+            <a:avLst/>
+          </a:prstGeom>
+          <a:noFill/>
+          <a:ln/>
+        </p:spPr>
+        <p:txBody>
+          <a:bodyPr wrap="square" rtlCol="0" anchor="ctr"/>
+          <a:lstStyle/>
+          <a:p>
+            <a:pPr marL="0" indent="0">
+              <a:buNone/>
+            </a:pPr>
+            <a:r>
+              <a:rPr lang="en-US" sz="2000" b="1" dirty="0">
+                <a:solidFill>
+                  <a:srgbClr val="FFFFFF"/>
+                </a:solidFill>
+                <a:latin typeface="Arial" pitchFamily="34" charset="0"/>
+                <a:ea typeface="Arial" pitchFamily="34" charset="-122"/>
+                <a:cs typeface="Arial" pitchFamily="34" charset="-120"/>
+              </a:rPr>
+              <a:t>1. Fully tested: </a:t>
+            </a:r>
+            <a:r>
+              <a:rPr lang="en-US" sz="2000" dirty="0">
+                <a:solidFill>
+                  <a:srgbClr val="FFFFFF"/>
+                </a:solidFill>
+                <a:latin typeface="Arial" pitchFamily="34" charset="0"/>
+                <a:ea typeface="Arial" pitchFamily="34" charset="-122"/>
+                <a:cs typeface="Arial" pitchFamily="34" charset="-120"/>
+              </a:rPr>
+              <a:t>28 integration tests across 5 modules — all passed against PythonAnywhere.</a:t>
+            </a:r>
+            <a:endParaRPr lang="en-US" sz="2000" dirty="0"/>
+          </a:p>
+          <a:p>
+            <a:pPr marL="0" indent="0">
+              <a:buNone/>
+            </a:pPr>
+            <a:endParaRPr lang="en-US" sz="2000" dirty="0"/>
+          </a:p>
+          <a:p>
+            <a:pPr marL="0" indent="0">
+              <a:buNone/>
+            </a:pPr>
+            <a:r>
+              <a:rPr lang="en-US" sz="2000" b="1" dirty="0">
+                <a:solidFill>
+                  <a:srgbClr val="FFFFFF"/>
+                </a:solidFill>
+                <a:latin typeface="Arial" pitchFamily="34" charset="0"/>
+                <a:ea typeface="Arial" pitchFamily="34" charset="-122"/>
+                <a:cs typeface="Arial" pitchFamily="34" charset="-120"/>
+              </a:rPr>
+              <a:t>2. Deployed: </a:t>
+            </a:r>
+            <a:r>
+              <a:rPr lang="en-US" sz="2000" dirty="0">
+                <a:solidFill>
+                  <a:srgbClr val="FFFFFF"/>
+                </a:solidFill>
+                <a:latin typeface="Arial" pitchFamily="34" charset="0"/>
+                <a:ea typeface="Arial" pitchFamily="34" charset="-122"/>
+                <a:cs typeface="Arial" pitchFamily="34" charset="-120"/>
+              </a:rPr>
+              <a:t>PythonAnywhere free tier with custom ASGI→WSGI bridge (3 iterations to solve).</a:t>
+            </a:r>
+            <a:endParaRPr lang="en-US" sz="2000" dirty="0"/>
+          </a:p>
+          <a:p>
+            <a:pPr marL="0" indent="0">
+              <a:buNone/>
+            </a:pPr>
+            <a:endParaRPr lang="en-US" sz="2000" dirty="0"/>
+          </a:p>
+          <a:p>
+            <a:pPr marL="0" indent="0">
+              <a:buNone/>
+            </a:pPr>
+            <a:r>
+              <a:rPr lang="en-US" sz="2000" b="1" dirty="0">
+                <a:solidFill>
+                  <a:srgbClr val="FFFFFF"/>
+                </a:solidFill>
+                <a:latin typeface="Arial" pitchFamily="34" charset="0"/>
+                <a:ea typeface="Arial" pitchFamily="34" charset="-122"/>
+                <a:cs typeface="Arial" pitchFamily="34" charset="-120"/>
+              </a:rPr>
+              <a:t>3. MCP-enabled: </a:t>
+            </a:r>
+            <a:r>
+              <a:rPr lang="en-US" sz="2000" dirty="0">
+                <a:solidFill>
+                  <a:srgbClr val="FFFFFF"/>
+                </a:solidFill>
+                <a:latin typeface="Arial" pitchFamily="34" charset="0"/>
+                <a:ea typeface="Arial" pitchFamily="34" charset="-122"/>
+                <a:cs typeface="Arial" pitchFamily="34" charset="-120"/>
+              </a:rPr>
+              <a:t>16 tools allow AI assistants to interact with the entire API via natural language.</a:t>
+            </a:r>
+            <a:endParaRPr lang="en-US" sz="2000" dirty="0"/>
+          </a:p>
+          <a:p>
+            <a:pPr marL="0" indent="0">
+              <a:buNone/>
+            </a:pPr>
+            <a:endParaRPr lang="en-US" sz="2000" dirty="0"/>
+          </a:p>
+          <a:p>
+            <a:pPr marL="0" indent="0">
+              <a:buNone/>
+            </a:pPr>
+            <a:r>
+              <a:rPr lang="en-US" sz="2000" b="1" dirty="0">
+                <a:solidFill>
+                  <a:srgbClr val="FFFFFF"/>
+                </a:solidFill>
+                <a:latin typeface="Arial" pitchFamily="34" charset="0"/>
+                <a:ea typeface="Arial" pitchFamily="34" charset="-122"/>
+                <a:cs typeface="Arial" pitchFamily="34" charset="-120"/>
+              </a:rPr>
+              <a:t>4. GenAI-assisted: </a:t>
+            </a:r>
+            <a:r>
+              <a:rPr lang="en-US" sz="2000" dirty="0">
+                <a:solidFill>
+                  <a:srgbClr val="FFFFFF"/>
+                </a:solidFill>
+                <a:latin typeface="Arial" pitchFamily="34" charset="0"/>
+                <a:ea typeface="Arial" pitchFamily="34" charset="-122"/>
+                <a:cs typeface="Arial" pitchFamily="34" charset="-120"/>
+              </a:rPr>
+              <a:t>GitHub Copilot + Claude Code (Opus 4.6) for planning, coding, debugging, and docs.</a:t>
+            </a:r>
+            <a:endParaRPr lang="en-US" sz="2000" dirty="0"/>
+          </a:p>
+        </p:txBody>
+      </p:sp>
+      <p:sp>
+        <p:nvSpPr>
+          <p:cNvPr id="5" name="Text 3"/>
+          <p:cNvSpPr/>
+          <p:nvPr/>
+        </p:nvSpPr>
+        <p:spPr>
+          <a:xfrm>
+            <a:off x="457200" y="4206240"/>
+            <a:ext cx="6400800" cy="274320"/>
+          </a:xfrm>
+          <a:prstGeom prst="rect">
+            <a:avLst/>
+          </a:prstGeom>
+          <a:noFill/>
+          <a:ln/>
+        </p:spPr>
+        <p:txBody>
+          <a:bodyPr wrap="square" rtlCol="0" anchor="ctr"/>
+          <a:lstStyle/>
+          <a:p>
+            <a:pPr marL="0" indent="0">
+              <a:buNone/>
+            </a:pPr>
+            <a:r>
+              <a:rPr lang="en-US" sz="1300" dirty="0">
+                <a:solidFill>
+                  <a:srgbClr val="A0BBDD"/>
+                </a:solidFill>
+                <a:latin typeface="Arial" pitchFamily="34" charset="0"/>
+                <a:ea typeface="Arial" pitchFamily="34" charset="-122"/>
+                <a:cs typeface="Arial" pitchFamily="34" charset="-120"/>
+              </a:rPr>
+              <a:t>Chenxi Li  ·  GitHub: github.com/lcx-0504/Web-Service-and-Data-CW1</a:t>
+            </a:r>
+            <a:endParaRPr lang="en-US" sz="1300" dirty="0"/>
+          </a:p>
+        </p:txBody>
+      </p:sp>
+      <p:sp>
+        <p:nvSpPr>
+          <p:cNvPr id="6" name="Text 4"/>
+          <p:cNvSpPr/>
+          <p:nvPr/>
+        </p:nvSpPr>
+        <p:spPr>
+          <a:xfrm>
+            <a:off x="457200" y="4572000"/>
+            <a:ext cx="8229600" cy="365760"/>
+          </a:xfrm>
+          <a:prstGeom prst="rect">
+            <a:avLst/>
+          </a:prstGeom>
+          <a:noFill/>
+          <a:ln/>
+        </p:spPr>
+        <p:txBody>
+          <a:bodyPr wrap="square" rtlCol="0" anchor="ctr"/>
+          <a:lstStyle/>
+          <a:p>
+            <a:pPr marL="0" indent="0">
+              <a:buNone/>
+            </a:pPr>
+            <a:r>
+              <a:rPr lang="en-US" sz="1800" b="1" dirty="0">
+                <a:solidFill>
+                  <a:srgbClr val="CADCFC"/>
+                </a:solidFill>
+                <a:latin typeface="Arial" pitchFamily="34" charset="0"/>
+                <a:ea typeface="Arial" pitchFamily="34" charset="-122"/>
+                <a:cs typeface="Arial" pitchFamily="34" charset="-120"/>
+              </a:rPr>
+              <a:t>Thank you — Questions?</a:t>
+            </a:r>
+            <a:endParaRPr lang="en-US" sz="1800" dirty="0"/>
           </a:p>
         </p:txBody>
       </p:sp>
@@ -3857,6 +4513,282 @@
 
 <file path=ppt/slides/slide5.xml><?xml version="1.0" encoding="utf-8"?>
 <p:sld xmlns:a="http://schemas.openxmlformats.org/drawingml/2006/main" xmlns:r="http://schemas.openxmlformats.org/officeDocument/2006/relationships" xmlns:p="http://schemas.openxmlformats.org/presentationml/2006/main">
+  <p:cSld>
+    <p:spTree>
+      <p:nvGrpSpPr>
+        <p:cNvPr id="1" name="">
+          <a:extLst>
+            <a:ext uri="{FF2B5EF4-FFF2-40B4-BE49-F238E27FC236}">
+              <a16:creationId xmlns:a16="http://schemas.microsoft.com/office/drawing/2014/main" id="{833337D6-D506-0A98-6325-634FC9222C0A}"/>
+            </a:ext>
+          </a:extLst>
+        </p:cNvPr>
+        <p:cNvGrpSpPr/>
+        <p:nvPr/>
+      </p:nvGrpSpPr>
+      <p:grpSpPr>
+        <a:xfrm>
+          <a:off x="0" y="0"/>
+          <a:ext cx="0" cy="0"/>
+          <a:chOff x="0" y="0"/>
+          <a:chExt cx="0" cy="0"/>
+        </a:xfrm>
+      </p:grpSpPr>
+      <p:sp>
+        <p:nvSpPr>
+          <p:cNvPr id="2" name="Text 0">
+            <a:extLst>
+              <a:ext uri="{FF2B5EF4-FFF2-40B4-BE49-F238E27FC236}">
+                <a16:creationId xmlns:a16="http://schemas.microsoft.com/office/drawing/2014/main" id="{312178BA-9893-086B-FE34-77DF1F39DACF}"/>
+              </a:ext>
+            </a:extLst>
+          </p:cNvPr>
+          <p:cNvSpPr/>
+          <p:nvPr/>
+        </p:nvSpPr>
+        <p:spPr>
+          <a:xfrm>
+            <a:off x="457200" y="182880"/>
+            <a:ext cx="8229600" cy="731520"/>
+          </a:xfrm>
+          <a:prstGeom prst="rect">
+            <a:avLst/>
+          </a:prstGeom>
+          <a:noFill/>
+          <a:ln/>
+        </p:spPr>
+        <p:txBody>
+          <a:bodyPr wrap="square" rtlCol="0" anchor="ctr"/>
+          <a:lstStyle/>
+          <a:p>
+            <a:pPr marL="0" indent="0">
+              <a:buNone/>
+            </a:pPr>
+            <a:r>
+              <a:rPr lang="en-US" altLang="zh-CN" sz="2400" b="1" dirty="0">
+                <a:solidFill>
+                  <a:srgbClr val="1F4E79"/>
+                </a:solidFill>
+                <a:latin typeface="Arial" pitchFamily="34" charset="0"/>
+                <a:ea typeface="Arial" pitchFamily="34" charset="-122"/>
+                <a:cs typeface="Arial" pitchFamily="34" charset="-120"/>
+              </a:rPr>
+              <a:t>Database ER Diagram</a:t>
+            </a:r>
+            <a:endParaRPr lang="en-US" sz="2400" dirty="0"/>
+          </a:p>
+        </p:txBody>
+      </p:sp>
+      <p:sp>
+        <p:nvSpPr>
+          <p:cNvPr id="3" name="Shape 1">
+            <a:extLst>
+              <a:ext uri="{FF2B5EF4-FFF2-40B4-BE49-F238E27FC236}">
+                <a16:creationId xmlns:a16="http://schemas.microsoft.com/office/drawing/2014/main" id="{FEE9697B-0C5C-7A24-71E4-7B3D5A3BF024}"/>
+              </a:ext>
+            </a:extLst>
+          </p:cNvPr>
+          <p:cNvSpPr/>
+          <p:nvPr/>
+        </p:nvSpPr>
+        <p:spPr>
+          <a:xfrm>
+            <a:off x="457200" y="914400"/>
+            <a:ext cx="8229600" cy="22860"/>
+          </a:xfrm>
+          <a:prstGeom prst="rect">
+            <a:avLst/>
+          </a:prstGeom>
+          <a:solidFill>
+            <a:srgbClr val="CCCCCC"/>
+          </a:solidFill>
+          <a:ln/>
+        </p:spPr>
+        <p:txBody>
+          <a:bodyPr/>
+          <a:lstStyle/>
+          <a:p>
+            <a:endParaRPr lang="zh-CN" altLang="en-US"/>
+          </a:p>
+        </p:txBody>
+      </p:sp>
+      <p:pic>
+        <p:nvPicPr>
+          <p:cNvPr id="13" name="图片 12">
+            <a:extLst>
+              <a:ext uri="{FF2B5EF4-FFF2-40B4-BE49-F238E27FC236}">
+                <a16:creationId xmlns:a16="http://schemas.microsoft.com/office/drawing/2014/main" id="{98327036-B300-4ED0-D09C-AD6839D14BA9}"/>
+              </a:ext>
+            </a:extLst>
+          </p:cNvPr>
+          <p:cNvPicPr>
+            <a:picLocks noChangeAspect="1"/>
+          </p:cNvPicPr>
+          <p:nvPr/>
+        </p:nvPicPr>
+        <p:blipFill>
+          <a:blip r:embed="rId3"/>
+          <a:stretch>
+            <a:fillRect/>
+          </a:stretch>
+        </p:blipFill>
+        <p:spPr>
+          <a:xfrm>
+            <a:off x="457200" y="1232109"/>
+            <a:ext cx="8229600" cy="2497207"/>
+          </a:xfrm>
+          <a:prstGeom prst="rect">
+            <a:avLst/>
+          </a:prstGeom>
+        </p:spPr>
+      </p:pic>
+      <p:sp>
+        <p:nvSpPr>
+          <p:cNvPr id="15" name="文本框 14">
+            <a:extLst>
+              <a:ext uri="{FF2B5EF4-FFF2-40B4-BE49-F238E27FC236}">
+                <a16:creationId xmlns:a16="http://schemas.microsoft.com/office/drawing/2014/main" id="{B465DBC0-B850-C5B6-90D3-3DBCFDD56850}"/>
+              </a:ext>
+            </a:extLst>
+          </p:cNvPr>
+          <p:cNvSpPr txBox="1"/>
+          <p:nvPr/>
+        </p:nvSpPr>
+        <p:spPr>
+          <a:xfrm>
+            <a:off x="457200" y="3865166"/>
+            <a:ext cx="8229600" cy="830997"/>
+          </a:xfrm>
+          <a:prstGeom prst="rect">
+            <a:avLst/>
+          </a:prstGeom>
+          <a:noFill/>
+        </p:spPr>
+        <p:txBody>
+          <a:bodyPr wrap="square">
+            <a:spAutoFit/>
+          </a:bodyPr>
+          <a:lstStyle/>
+          <a:p>
+            <a:r>
+              <a:rPr lang="en" altLang="zh-CN" sz="1600" b="1" i="0" dirty="0">
+                <a:solidFill>
+                  <a:srgbClr val="1F2328"/>
+                </a:solidFill>
+                <a:effectLst/>
+                <a:latin typeface="-apple-system"/>
+              </a:rPr>
+              <a:t>Relationships:</a:t>
+            </a:r>
+            <a:r>
+              <a:rPr lang="en" altLang="zh-CN" sz="1600" b="0" i="0" dirty="0">
+                <a:solidFill>
+                  <a:srgbClr val="1F2328"/>
+                </a:solidFill>
+                <a:effectLst/>
+                <a:latin typeface="-apple-system"/>
+              </a:rPr>
+              <a:t> User 1 - N Meal (one user has many meals) · Meal 1 - N </a:t>
+            </a:r>
+            <a:r>
+              <a:rPr lang="en" altLang="zh-CN" sz="1600" b="0" i="0" dirty="0" err="1">
+                <a:solidFill>
+                  <a:srgbClr val="1F2328"/>
+                </a:solidFill>
+                <a:effectLst/>
+                <a:latin typeface="-apple-system"/>
+              </a:rPr>
+              <a:t>MealItem</a:t>
+            </a:r>
+            <a:r>
+              <a:rPr lang="en" altLang="zh-CN" sz="1600" b="0" i="0" dirty="0">
+                <a:solidFill>
+                  <a:srgbClr val="1F2328"/>
+                </a:solidFill>
+                <a:effectLst/>
+                <a:latin typeface="-apple-system"/>
+              </a:rPr>
+              <a:t> (one meal contains many items) · Food 1 - N </a:t>
+            </a:r>
+            <a:r>
+              <a:rPr lang="en" altLang="zh-CN" sz="1600" b="0" i="0" dirty="0" err="1">
+                <a:solidFill>
+                  <a:srgbClr val="1F2328"/>
+                </a:solidFill>
+                <a:effectLst/>
+                <a:latin typeface="-apple-system"/>
+              </a:rPr>
+              <a:t>MealItem</a:t>
+            </a:r>
+            <a:r>
+              <a:rPr lang="en" altLang="zh-CN" sz="1600" b="0" i="0" dirty="0">
+                <a:solidFill>
+                  <a:srgbClr val="1F2328"/>
+                </a:solidFill>
+                <a:effectLst/>
+                <a:latin typeface="-apple-system"/>
+              </a:rPr>
+              <a:t> (one food appears in many items) · </a:t>
+            </a:r>
+            <a:r>
+              <a:rPr lang="en" altLang="zh-CN" sz="1600" b="1" i="0" dirty="0">
+                <a:solidFill>
+                  <a:srgbClr val="1F2328"/>
+                </a:solidFill>
+                <a:effectLst/>
+                <a:latin typeface="-apple-system"/>
+              </a:rPr>
+              <a:t>Food N - N Meal</a:t>
+            </a:r>
+            <a:r>
+              <a:rPr lang="en" altLang="zh-CN" sz="1600" b="0" i="0" dirty="0">
+                <a:solidFill>
+                  <a:srgbClr val="1F2328"/>
+                </a:solidFill>
+                <a:effectLst/>
+                <a:latin typeface="-apple-system"/>
+              </a:rPr>
+              <a:t> (many-to-many via </a:t>
+            </a:r>
+            <a:r>
+              <a:rPr lang="en" altLang="zh-CN" sz="1600" b="0" i="0" dirty="0" err="1">
+                <a:solidFill>
+                  <a:srgbClr val="1F2328"/>
+                </a:solidFill>
+                <a:effectLst/>
+                <a:latin typeface="-apple-system"/>
+              </a:rPr>
+              <a:t>MealItem</a:t>
+            </a:r>
+            <a:r>
+              <a:rPr lang="en" altLang="zh-CN" sz="1600" b="0" i="0" dirty="0">
+                <a:solidFill>
+                  <a:srgbClr val="1F2328"/>
+                </a:solidFill>
+                <a:effectLst/>
+                <a:latin typeface="-apple-system"/>
+              </a:rPr>
+              <a:t> junction table)</a:t>
+            </a:r>
+            <a:endParaRPr lang="zh-CN" altLang="en-US" sz="1600" dirty="0"/>
+          </a:p>
+        </p:txBody>
+      </p:sp>
+    </p:spTree>
+    <p:extLst>
+      <p:ext uri="{BB962C8B-B14F-4D97-AF65-F5344CB8AC3E}">
+        <p14:creationId xmlns:p14="http://schemas.microsoft.com/office/powerpoint/2010/main" val="1605016667"/>
+      </p:ext>
+    </p:extLst>
+  </p:cSld>
+  <p:clrMapOvr>
+    <a:masterClrMapping/>
+  </p:clrMapOvr>
+</p:sld>
+</file>
+
+<file path=ppt/slides/slide6.xml><?xml version="1.0" encoding="utf-8"?>
+<p:sld xmlns:a="http://schemas.openxmlformats.org/drawingml/2006/main" xmlns:r="http://schemas.openxmlformats.org/officeDocument/2006/relationships" xmlns:p="http://schemas.openxmlformats.org/presentationml/2006/main">
   <p:cSld name="Slide 5">
     <p:spTree>
       <p:nvGrpSpPr>
@@ -4363,7 +5295,7 @@
 </p:sld>
 </file>
 
-<file path=ppt/slides/slide6.xml><?xml version="1.0" encoding="utf-8"?>
+<file path=ppt/slides/slide7.xml><?xml version="1.0" encoding="utf-8"?>
 <p:sld xmlns:a="http://schemas.openxmlformats.org/drawingml/2006/main" xmlns:r="http://schemas.openxmlformats.org/officeDocument/2006/relationships" xmlns:p="http://schemas.openxmlformats.org/presentationml/2006/main">
   <p:cSld name="Slide 6">
     <p:spTree>
@@ -4493,8 +5425,8 @@
         </p:nvSpPr>
         <p:spPr>
           <a:xfrm>
-            <a:off x="457200" y="1554480"/>
-            <a:ext cx="3840480" cy="2286000"/>
+            <a:off x="445347" y="1436792"/>
+            <a:ext cx="3840480" cy="2217421"/>
           </a:xfrm>
           <a:prstGeom prst="rect">
             <a:avLst/>
@@ -4561,7 +5493,29 @@
                 <a:ea typeface="Arial" pitchFamily="34" charset="-122"/>
                 <a:cs typeface="Arial" pitchFamily="34" charset="-120"/>
               </a:rPr>
-              <a:t>3. AI shows summary → get_daily_summary tool</a:t>
+              <a:t>3. AI shows summary → </a:t>
+            </a:r>
+            <a:r>
+              <a:rPr lang="en-US" sz="1800" dirty="0" err="1">
+                <a:solidFill>
+                  <a:srgbClr val="2D2D2D"/>
+                </a:solidFill>
+                <a:latin typeface="Arial" pitchFamily="34" charset="0"/>
+                <a:ea typeface="Arial" pitchFamily="34" charset="-122"/>
+                <a:cs typeface="Arial" pitchFamily="34" charset="-120"/>
+              </a:rPr>
+              <a:t>get_daily_summary</a:t>
+            </a:r>
+            <a:r>
+              <a:rPr lang="en-US" sz="1800" dirty="0">
+                <a:solidFill>
+                  <a:srgbClr val="2D2D2D"/>
+                </a:solidFill>
+                <a:latin typeface="Arial" pitchFamily="34" charset="0"/>
+                <a:ea typeface="Arial" pitchFamily="34" charset="-122"/>
+                <a:cs typeface="Arial" pitchFamily="34" charset="-120"/>
+              </a:rPr>
+              <a:t> tool</a:t>
             </a:r>
             <a:endParaRPr lang="en-US" sz="1800" dirty="0"/>
           </a:p>
@@ -4572,17 +5526,8 @@
               </a:spcAft>
               <a:buNone/>
             </a:pPr>
-            <a:endParaRPr lang="en-US" sz="1800" dirty="0"/>
-          </a:p>
-          <a:p>
-            <a:pPr marL="0" indent="0">
-              <a:spcAft>
-                <a:spcPts val="800"/>
-              </a:spcAft>
-              <a:buNone/>
-            </a:pPr>
-            <a:r>
-              <a:rPr lang="en-US" sz="1800" i="1" dirty="0">
+            <a:r>
+              <a:rPr lang="en-US" sz="1400" i="1" dirty="0">
                 <a:solidFill>
                   <a:srgbClr val="2D2D2D"/>
                 </a:solidFill>
@@ -4592,7 +5537,7 @@
               </a:rPr>
               <a:t>Claude Desktop discovers all 16 tools automatically</a:t>
             </a:r>
-            <a:endParaRPr lang="en-US" sz="1800" dirty="0"/>
+            <a:endParaRPr lang="en-US" sz="1400" dirty="0"/>
           </a:p>
         </p:txBody>
       </p:sp>
@@ -4643,7 +5588,7 @@
         </p:nvSpPr>
         <p:spPr>
           <a:xfrm>
-            <a:off x="4846320" y="1554480"/>
+            <a:off x="4846320" y="1368213"/>
             <a:ext cx="3840480" cy="2286000"/>
           </a:xfrm>
           <a:prstGeom prst="rect">
@@ -4820,8 +5765,8 @@
         </p:nvSpPr>
         <p:spPr>
           <a:xfrm>
-            <a:off x="457200" y="4709160"/>
-            <a:ext cx="8229600" cy="320040"/>
+            <a:off x="4858175" y="3654213"/>
+            <a:ext cx="4285825" cy="1166705"/>
           </a:xfrm>
           <a:prstGeom prst="rect">
             <a:avLst/>
@@ -4833,7 +5778,36 @@
           <a:bodyPr wrap="square" rtlCol="0" anchor="ctr"/>
           <a:lstStyle/>
           <a:p>
-            <a:pPr marL="0" indent="0" algn="l">
+            <a:r>
+              <a:rPr lang="en" altLang="zh-CN" sz="1200" b="1" dirty="0">
+                <a:solidFill>
+                  <a:srgbClr val="777777"/>
+                </a:solidFill>
+                <a:latin typeface="Arial" pitchFamily="34" charset="0"/>
+                <a:cs typeface="Arial" pitchFamily="34" charset="-120"/>
+              </a:rPr>
+              <a:t>Online API Doc</a:t>
+            </a:r>
+            <a:r>
+              <a:rPr lang="en-US" altLang="zh-CN" sz="1200" b="1" dirty="0">
+                <a:solidFill>
+                  <a:srgbClr val="777777"/>
+                </a:solidFill>
+                <a:latin typeface="Arial" pitchFamily="34" charset="0"/>
+                <a:cs typeface="Arial" pitchFamily="34" charset="-120"/>
+              </a:rPr>
+              <a:t>: </a:t>
+            </a:r>
+            <a:endParaRPr lang="en-US" sz="1200" b="1" dirty="0">
+              <a:solidFill>
+                <a:srgbClr val="777777"/>
+              </a:solidFill>
+              <a:latin typeface="Arial" pitchFamily="34" charset="0"/>
+              <a:cs typeface="Arial" pitchFamily="34" charset="-120"/>
+            </a:endParaRPr>
+          </a:p>
+          <a:p>
+            <a:pPr marL="0" indent="0">
               <a:buNone/>
             </a:pPr>
             <a:r>
@@ -4845,9 +5819,222 @@
                 <a:ea typeface="Arial" pitchFamily="34" charset="-122"/>
                 <a:cs typeface="Arial" pitchFamily="34" charset="-120"/>
               </a:rPr>
-              <a:t>Live: https://lichenxi.pythonanywhere.com/docs</a:t>
-            </a:r>
-            <a:endParaRPr lang="en-US" sz="1200" dirty="0"/>
+              <a:t>Swagger</a:t>
+            </a:r>
+            <a:r>
+              <a:rPr lang="zh-CN" altLang="en-US" sz="1200" dirty="0">
+                <a:solidFill>
+                  <a:srgbClr val="777777"/>
+                </a:solidFill>
+                <a:latin typeface="Arial" pitchFamily="34" charset="0"/>
+                <a:ea typeface="Arial" pitchFamily="34" charset="-122"/>
+                <a:cs typeface="Arial" pitchFamily="34" charset="-120"/>
+              </a:rPr>
+              <a:t> </a:t>
+            </a:r>
+            <a:r>
+              <a:rPr lang="en-US" altLang="zh-CN" sz="1200" dirty="0">
+                <a:solidFill>
+                  <a:srgbClr val="777777"/>
+                </a:solidFill>
+                <a:latin typeface="Arial" pitchFamily="34" charset="0"/>
+                <a:ea typeface="Arial" pitchFamily="34" charset="-122"/>
+                <a:cs typeface="Arial" pitchFamily="34" charset="-120"/>
+              </a:rPr>
+              <a:t>UI</a:t>
+            </a:r>
+            <a:r>
+              <a:rPr lang="zh-CN" altLang="en-US" sz="1200" dirty="0">
+                <a:solidFill>
+                  <a:srgbClr val="777777"/>
+                </a:solidFill>
+                <a:latin typeface="Arial" pitchFamily="34" charset="0"/>
+                <a:ea typeface="Arial" pitchFamily="34" charset="-122"/>
+                <a:cs typeface="Arial" pitchFamily="34" charset="-120"/>
+              </a:rPr>
+              <a:t> </a:t>
+            </a:r>
+            <a:r>
+              <a:rPr lang="en-US" sz="1200" dirty="0" err="1">
+                <a:solidFill>
+                  <a:srgbClr val="777777"/>
+                </a:solidFill>
+                <a:latin typeface="Arial" pitchFamily="34" charset="0"/>
+                <a:ea typeface="Arial" pitchFamily="34" charset="-122"/>
+                <a:cs typeface="Arial" pitchFamily="34" charset="-120"/>
+              </a:rPr>
+              <a:t>Live:</a:t>
+            </a:r>
+            <a:r>
+              <a:rPr lang="en-US" sz="1200" dirty="0" err="1">
+                <a:solidFill>
+                  <a:srgbClr val="777777"/>
+                </a:solidFill>
+                <a:latin typeface="Arial" pitchFamily="34" charset="0"/>
+                <a:ea typeface="Arial" pitchFamily="34" charset="-122"/>
+                <a:cs typeface="Arial" pitchFamily="34" charset="-120"/>
+                <a:hlinkClick r:id="rId3"/>
+              </a:rPr>
+              <a:t>https</a:t>
+            </a:r>
+            <a:r>
+              <a:rPr lang="en-US" sz="1200" dirty="0">
+                <a:solidFill>
+                  <a:srgbClr val="777777"/>
+                </a:solidFill>
+                <a:latin typeface="Arial" pitchFamily="34" charset="0"/>
+                <a:ea typeface="Arial" pitchFamily="34" charset="-122"/>
+                <a:cs typeface="Arial" pitchFamily="34" charset="-120"/>
+                <a:hlinkClick r:id="rId3"/>
+              </a:rPr>
+              <a:t>://lichenxi.pythonanywhere.com/docs</a:t>
+            </a:r>
+            <a:endParaRPr lang="en-US" sz="1200" dirty="0">
+              <a:solidFill>
+                <a:srgbClr val="777777"/>
+              </a:solidFill>
+              <a:latin typeface="Arial" pitchFamily="34" charset="0"/>
+              <a:ea typeface="Arial" pitchFamily="34" charset="-122"/>
+              <a:cs typeface="Arial" pitchFamily="34" charset="-120"/>
+            </a:endParaRPr>
+          </a:p>
+          <a:p>
+            <a:r>
+              <a:rPr lang="en-US" sz="1200" dirty="0" err="1">
+                <a:solidFill>
+                  <a:srgbClr val="777777"/>
+                </a:solidFill>
+                <a:latin typeface="Arial" pitchFamily="34" charset="0"/>
+                <a:cs typeface="Arial" pitchFamily="34" charset="-120"/>
+              </a:rPr>
+              <a:t>ReDoc:</a:t>
+            </a:r>
+            <a:r>
+              <a:rPr lang="en-US" sz="1200" dirty="0" err="1">
+                <a:solidFill>
+                  <a:srgbClr val="777777"/>
+                </a:solidFill>
+                <a:latin typeface="Arial" pitchFamily="34" charset="0"/>
+                <a:cs typeface="Arial" pitchFamily="34" charset="-120"/>
+                <a:hlinkClick r:id="rId4"/>
+              </a:rPr>
+              <a:t>https</a:t>
+            </a:r>
+            <a:r>
+              <a:rPr lang="en-US" sz="1200" dirty="0">
+                <a:solidFill>
+                  <a:srgbClr val="777777"/>
+                </a:solidFill>
+                <a:latin typeface="Arial" pitchFamily="34" charset="0"/>
+                <a:cs typeface="Arial" pitchFamily="34" charset="-120"/>
+                <a:hlinkClick r:id="rId4"/>
+              </a:rPr>
+              <a:t>://lichenxi.pythonanywhere.com/redoc</a:t>
+            </a:r>
+            <a:endParaRPr lang="en-US" sz="1200" dirty="0">
+              <a:solidFill>
+                <a:srgbClr val="777777"/>
+              </a:solidFill>
+              <a:latin typeface="Arial" pitchFamily="34" charset="0"/>
+              <a:cs typeface="Arial" pitchFamily="34" charset="-120"/>
+            </a:endParaRPr>
+          </a:p>
+        </p:txBody>
+      </p:sp>
+      <p:sp>
+        <p:nvSpPr>
+          <p:cNvPr id="10" name="文本框 9">
+            <a:extLst>
+              <a:ext uri="{FF2B5EF4-FFF2-40B4-BE49-F238E27FC236}">
+                <a16:creationId xmlns:a16="http://schemas.microsoft.com/office/drawing/2014/main" id="{024D500D-254D-EC71-B86D-93DF2C147AD5}"/>
+              </a:ext>
+            </a:extLst>
+          </p:cNvPr>
+          <p:cNvSpPr txBox="1"/>
+          <p:nvPr/>
+        </p:nvSpPr>
+        <p:spPr>
+          <a:xfrm>
+            <a:off x="445347" y="3505623"/>
+            <a:ext cx="4400973" cy="1463885"/>
+          </a:xfrm>
+          <a:prstGeom prst="rect">
+            <a:avLst/>
+          </a:prstGeom>
+          <a:noFill/>
+          <a:ln/>
+        </p:spPr>
+        <p:txBody>
+          <a:bodyPr wrap="square" rtlCol="0" anchor="ctr"/>
+          <a:lstStyle>
+            <a:lvl1pPr indent="0" algn="r">
+              <a:buNone/>
+              <a:defRPr sz="1200">
+                <a:solidFill>
+                  <a:srgbClr val="777777"/>
+                </a:solidFill>
+                <a:latin typeface="Arial" pitchFamily="34" charset="0"/>
+                <a:ea typeface="Arial" pitchFamily="34" charset="-122"/>
+                <a:cs typeface="Arial" pitchFamily="34" charset="-120"/>
+              </a:defRPr>
+            </a:lvl1pPr>
+          </a:lstStyle>
+          <a:p>
+            <a:pPr algn="l"/>
+            <a:r>
+              <a:rPr lang="en" altLang="zh-CN" b="1" dirty="0"/>
+              <a:t>MCP</a:t>
+            </a:r>
+            <a:r>
+              <a:rPr lang="en-US" altLang="zh-CN" b="1" dirty="0"/>
+              <a:t> Video: </a:t>
+            </a:r>
+            <a:endParaRPr lang="en" altLang="zh-CN" b="1" dirty="0"/>
+          </a:p>
+          <a:p>
+            <a:pPr algn="l"/>
+            <a:r>
+              <a:rPr lang="en" altLang="zh-CN" dirty="0"/>
+              <a:t>OneDrive (login required): </a:t>
+            </a:r>
+            <a:r>
+              <a:rPr lang="en" altLang="zh-CN" dirty="0">
+                <a:hlinkClick r:id="rId5"/>
+              </a:rPr>
+              <a:t>Nutritrack MCP Test.mp4</a:t>
+            </a:r>
+            <a:endParaRPr lang="en" altLang="zh-CN" dirty="0"/>
+          </a:p>
+          <a:p>
+            <a:pPr algn="l"/>
+            <a:r>
+              <a:rPr lang="en" altLang="zh-CN" dirty="0"/>
+              <a:t>Google Drive: </a:t>
+            </a:r>
+            <a:r>
+              <a:rPr lang="en" altLang="zh-CN" dirty="0">
+                <a:hlinkClick r:id="rId6"/>
+              </a:rPr>
+              <a:t>Nutritrack MCP Test.mp4</a:t>
+            </a:r>
+            <a:endParaRPr lang="en" altLang="zh-CN" dirty="0"/>
+          </a:p>
+          <a:p>
+            <a:pPr algn="l"/>
+            <a:r>
+              <a:rPr lang="en" altLang="zh-CN" dirty="0"/>
+              <a:t>Baidu Pan: </a:t>
+            </a:r>
+            <a:r>
+              <a:rPr lang="en" altLang="zh-CN" dirty="0">
+                <a:hlinkClick r:id="rId7"/>
+              </a:rPr>
+              <a:t>Nutritrack MCP Test.mp4</a:t>
+            </a:r>
+            <a:r>
+              <a:rPr lang="en" altLang="zh-CN" dirty="0"/>
+              <a:t> (Password: q3md)</a:t>
+            </a:r>
           </a:p>
         </p:txBody>
       </p:sp>
@@ -4859,20 +6046,18 @@
 </p:sld>
 </file>
 
-<file path=ppt/slides/slide7.xml><?xml version="1.0" encoding="utf-8"?>
+<file path=ppt/slides/slide8.xml><?xml version="1.0" encoding="utf-8"?>
 <p:sld xmlns:a="http://schemas.openxmlformats.org/drawingml/2006/main" xmlns:r="http://schemas.openxmlformats.org/officeDocument/2006/relationships" xmlns:p="http://schemas.openxmlformats.org/presentationml/2006/main">
-  <p:cSld name="Slide 7">
-    <p:bg>
-      <p:bgPr>
-        <a:solidFill>
-          <a:srgbClr val="1F4E79"/>
-        </a:solidFill>
-        <a:effectLst/>
-      </p:bgPr>
-    </p:bg>
+  <p:cSld>
     <p:spTree>
       <p:nvGrpSpPr>
-        <p:cNvPr id="1" name=""/>
+        <p:cNvPr id="1" name="">
+          <a:extLst>
+            <a:ext uri="{FF2B5EF4-FFF2-40B4-BE49-F238E27FC236}">
+              <a16:creationId xmlns:a16="http://schemas.microsoft.com/office/drawing/2014/main" id="{DC76A04F-372D-A17C-4A90-3E9868FDC3D5}"/>
+            </a:ext>
+          </a:extLst>
+        </p:cNvPr>
         <p:cNvGrpSpPr/>
         <p:nvPr/>
       </p:nvGrpSpPr>
@@ -4886,14 +6071,20 @@
       </p:grpSpPr>
       <p:sp>
         <p:nvSpPr>
-          <p:cNvPr id="2" name="Text 0"/>
+          <p:cNvPr id="2" name="Text 0">
+            <a:extLst>
+              <a:ext uri="{FF2B5EF4-FFF2-40B4-BE49-F238E27FC236}">
+                <a16:creationId xmlns:a16="http://schemas.microsoft.com/office/drawing/2014/main" id="{B54D4202-2536-4CD0-8B8C-69D369896565}"/>
+              </a:ext>
+            </a:extLst>
+          </p:cNvPr>
           <p:cNvSpPr/>
           <p:nvPr/>
         </p:nvSpPr>
         <p:spPr>
           <a:xfrm>
             <a:off x="457200" y="182880"/>
-            <a:ext cx="8229600" cy="365760"/>
+            <a:ext cx="8229600" cy="471022"/>
           </a:xfrm>
           <a:prstGeom prst="rect">
             <a:avLst/>
@@ -4905,40 +6096,48 @@
           <a:bodyPr wrap="square" rtlCol="0" anchor="ctr"/>
           <a:lstStyle/>
           <a:p>
-            <a:pPr marL="0" indent="0">
-              <a:buNone/>
-            </a:pPr>
-            <a:r>
-              <a:rPr lang="en-US" sz="2000" dirty="0">
-                <a:solidFill>
-                  <a:srgbClr val="A0BBDD"/>
-                </a:solidFill>
-                <a:latin typeface="Arial" pitchFamily="34" charset="0"/>
-                <a:ea typeface="Arial" pitchFamily="34" charset="-122"/>
-                <a:cs typeface="Arial" pitchFamily="34" charset="-120"/>
-              </a:rPr>
-              <a:t>Conclusions</a:t>
-            </a:r>
-            <a:endParaRPr lang="en-US" sz="2000" dirty="0"/>
+            <a:pPr>
+              <a:defRPr sz="2800" b="1">
+                <a:solidFill>
+                  <a:srgbClr val="1A1A2E"/>
+                </a:solidFill>
+              </a:defRPr>
+            </a:pPr>
+            <a:r>
+              <a:rPr lang="en" altLang="zh-CN" sz="2400" b="1" dirty="0">
+                <a:solidFill>
+                  <a:srgbClr val="1F4E79"/>
+                </a:solidFill>
+                <a:latin typeface="Arial" pitchFamily="34" charset="0"/>
+                <a:cs typeface="Arial" pitchFamily="34" charset="-120"/>
+              </a:rPr>
+              <a:t>Version Control &amp; Testing</a:t>
+            </a:r>
           </a:p>
         </p:txBody>
       </p:sp>
       <p:sp>
         <p:nvSpPr>
-          <p:cNvPr id="3" name="Shape 1"/>
+          <p:cNvPr id="3" name="Shape 1">
+            <a:extLst>
+              <a:ext uri="{FF2B5EF4-FFF2-40B4-BE49-F238E27FC236}">
+                <a16:creationId xmlns:a16="http://schemas.microsoft.com/office/drawing/2014/main" id="{77A0E008-6A3B-91C2-3184-5ED163322718}"/>
+              </a:ext>
+            </a:extLst>
+          </p:cNvPr>
           <p:cNvSpPr/>
           <p:nvPr/>
         </p:nvSpPr>
         <p:spPr>
           <a:xfrm>
-            <a:off x="457200" y="548640"/>
-            <a:ext cx="8229600" cy="36576"/>
+            <a:off x="457200" y="675169"/>
+            <a:ext cx="8229600" cy="22860"/>
           </a:xfrm>
           <a:prstGeom prst="rect">
             <a:avLst/>
           </a:prstGeom>
           <a:solidFill>
-            <a:srgbClr val="2E75B6"/>
+            <a:srgbClr val="CCCCCC"/>
           </a:solidFill>
           <a:ln/>
         </p:spPr>
@@ -4952,14 +6151,375 @@
       </p:sp>
       <p:sp>
         <p:nvSpPr>
-          <p:cNvPr id="4" name="Text 2"/>
+          <p:cNvPr id="12" name="TextBox 2">
+            <a:extLst>
+              <a:ext uri="{FF2B5EF4-FFF2-40B4-BE49-F238E27FC236}">
+                <a16:creationId xmlns:a16="http://schemas.microsoft.com/office/drawing/2014/main" id="{BF14A93C-391D-6BDE-9F17-E4D821E50102}"/>
+              </a:ext>
+            </a:extLst>
+          </p:cNvPr>
+          <p:cNvSpPr txBox="1"/>
+          <p:nvPr/>
+        </p:nvSpPr>
+        <p:spPr>
+          <a:xfrm>
+            <a:off x="457200" y="1038337"/>
+            <a:ext cx="5672470" cy="3565079"/>
+          </a:xfrm>
+          <a:prstGeom prst="rect">
+            <a:avLst/>
+          </a:prstGeom>
+          <a:noFill/>
+        </p:spPr>
+        <p:txBody>
+          <a:bodyPr wrap="square">
+            <a:spAutoFit/>
+          </a:bodyPr>
+          <a:lstStyle/>
+          <a:p>
+            <a:pPr>
+              <a:spcBef>
+                <a:spcPts val="1200"/>
+              </a:spcBef>
+              <a:defRPr sz="1800" b="1">
+                <a:solidFill>
+                  <a:srgbClr val="2D5A8E"/>
+                </a:solidFill>
+              </a:defRPr>
+            </a:pPr>
+            <a:r>
+              <a:rPr sz="1600" b="1" dirty="0">
+                <a:solidFill>
+                  <a:srgbClr val="2E75B6"/>
+                </a:solidFill>
+                <a:latin typeface="Arial" pitchFamily="34" charset="0"/>
+                <a:cs typeface="Arial" pitchFamily="34" charset="-120"/>
+              </a:rPr>
+              <a:t>Git History (16 commits)</a:t>
+            </a:r>
+          </a:p>
+          <a:p>
+            <a:pPr>
+              <a:spcBef>
+                <a:spcPts val="200"/>
+              </a:spcBef>
+              <a:defRPr sz="1400">
+                <a:solidFill>
+                  <a:srgbClr val="333333"/>
+                </a:solidFill>
+              </a:defRPr>
+            </a:pPr>
+            <a:r>
+              <a:rPr sz="1200" dirty="0"/>
+              <a:t>d0c475d  Initial commit</a:t>
+            </a:r>
+          </a:p>
+          <a:p>
+            <a:pPr>
+              <a:spcBef>
+                <a:spcPts val="200"/>
+              </a:spcBef>
+              <a:defRPr sz="1400">
+                <a:solidFill>
+                  <a:srgbClr val="333333"/>
+                </a:solidFill>
+              </a:defRPr>
+            </a:pPr>
+            <a:r>
+              <a:rPr sz="1200" dirty="0"/>
+              <a:t>27f54a1  feat: project skeleton, models, alembic migration, USDA import</a:t>
+            </a:r>
+          </a:p>
+          <a:p>
+            <a:pPr>
+              <a:spcBef>
+                <a:spcPts val="200"/>
+              </a:spcBef>
+              <a:defRPr sz="1400">
+                <a:solidFill>
+                  <a:srgbClr val="333333"/>
+                </a:solidFill>
+              </a:defRPr>
+            </a:pPr>
+            <a:r>
+              <a:rPr sz="1200" dirty="0"/>
+              <a:t>4a7d494  feat: JWT auth, Food read API, Meal CRUD</a:t>
+            </a:r>
+          </a:p>
+          <a:p>
+            <a:pPr>
+              <a:spcBef>
+                <a:spcPts val="200"/>
+              </a:spcBef>
+              <a:defRPr sz="1400">
+                <a:solidFill>
+                  <a:srgbClr val="333333"/>
+                </a:solidFill>
+              </a:defRPr>
+            </a:pPr>
+            <a:r>
+              <a:rPr sz="1200" dirty="0"/>
+              <a:t>6924269  feat: nutrition analytics (daily/weekly/balance)</a:t>
+            </a:r>
+          </a:p>
+          <a:p>
+            <a:pPr>
+              <a:spcBef>
+                <a:spcPts val="200"/>
+              </a:spcBef>
+              <a:defRPr sz="1400">
+                <a:solidFill>
+                  <a:srgbClr val="333333"/>
+                </a:solidFill>
+              </a:defRPr>
+            </a:pPr>
+            <a:r>
+              <a:rPr sz="1200" dirty="0"/>
+              <a:t>70637d4  feat: user profile + personalized nutrition + MCP tools</a:t>
+            </a:r>
+          </a:p>
+          <a:p>
+            <a:pPr>
+              <a:spcBef>
+                <a:spcPts val="200"/>
+              </a:spcBef>
+              <a:defRPr sz="1400">
+                <a:solidFill>
+                  <a:srgbClr val="333333"/>
+                </a:solidFill>
+              </a:defRPr>
+            </a:pPr>
+            <a:r>
+              <a:rPr sz="1200" dirty="0"/>
+              <a:t>1b744b7  feat: input validation — hard reject + soft warnings</a:t>
+            </a:r>
+          </a:p>
+          <a:p>
+            <a:pPr>
+              <a:spcBef>
+                <a:spcPts val="200"/>
+              </a:spcBef>
+              <a:defRPr sz="1400">
+                <a:solidFill>
+                  <a:srgbClr val="333333"/>
+                </a:solidFill>
+              </a:defRPr>
+            </a:pPr>
+            <a:r>
+              <a:rPr sz="1200" dirty="0"/>
+              <a:t>6789771  feat: search improvements + MCP demo assets</a:t>
+            </a:r>
+          </a:p>
+          <a:p>
+            <a:pPr>
+              <a:spcBef>
+                <a:spcPts val="200"/>
+              </a:spcBef>
+              <a:defRPr sz="1400">
+                <a:solidFill>
+                  <a:srgbClr val="333333"/>
+                </a:solidFill>
+              </a:defRPr>
+            </a:pPr>
+            <a:r>
+              <a:rPr sz="1200" dirty="0"/>
+              <a:t>f0b77d1  refactor: async → sync for PythonAnywhere WSGI</a:t>
+            </a:r>
+          </a:p>
+          <a:p>
+            <a:pPr>
+              <a:spcBef>
+                <a:spcPts val="200"/>
+              </a:spcBef>
+              <a:defRPr sz="1400">
+                <a:solidFill>
+                  <a:srgbClr val="333333"/>
+                </a:solidFill>
+              </a:defRPr>
+            </a:pPr>
+            <a:r>
+              <a:rPr sz="1200" dirty="0"/>
+              <a:t>82f5857  test: 28 integration tests with configurable base URL</a:t>
+            </a:r>
+          </a:p>
+          <a:p>
+            <a:pPr>
+              <a:spcBef>
+                <a:spcPts val="200"/>
+              </a:spcBef>
+              <a:defRPr sz="1400">
+                <a:solidFill>
+                  <a:srgbClr val="333333"/>
+                </a:solidFill>
+              </a:defRPr>
+            </a:pPr>
+            <a:r>
+              <a:rPr sz="1200" dirty="0"/>
+              <a:t>9f5e14d + 2c51ea0  docs: API docs, tech report, presentation, </a:t>
+            </a:r>
+            <a:r>
+              <a:rPr sz="1200" dirty="0" err="1"/>
+              <a:t>genai</a:t>
+            </a:r>
+            <a:r>
+              <a:rPr sz="1200" dirty="0"/>
+              <a:t> logs</a:t>
+            </a:r>
+          </a:p>
+          <a:p>
+            <a:pPr>
+              <a:spcBef>
+                <a:spcPts val="1200"/>
+              </a:spcBef>
+              <a:defRPr sz="1800" b="1">
+                <a:solidFill>
+                  <a:srgbClr val="2D5A8E"/>
+                </a:solidFill>
+              </a:defRPr>
+            </a:pPr>
+            <a:r>
+              <a:rPr sz="1600" b="1" dirty="0">
+                <a:solidFill>
+                  <a:srgbClr val="2E75B6"/>
+                </a:solidFill>
+                <a:latin typeface="Arial" pitchFamily="34" charset="0"/>
+                <a:cs typeface="Arial" pitchFamily="34" charset="-120"/>
+              </a:rPr>
+              <a:t>Testing (28 integration tests)</a:t>
+            </a:r>
+          </a:p>
+          <a:p>
+            <a:pPr>
+              <a:spcBef>
+                <a:spcPts val="200"/>
+              </a:spcBef>
+              <a:defRPr sz="1400">
+                <a:solidFill>
+                  <a:srgbClr val="333333"/>
+                </a:solidFill>
+              </a:defRPr>
+            </a:pPr>
+            <a:r>
+              <a:rPr sz="1200" dirty="0"/>
+              <a:t>Auth, Foods, Meals CRUD, Analytics, User Profile</a:t>
+            </a:r>
+          </a:p>
+          <a:p>
+            <a:pPr>
+              <a:spcBef>
+                <a:spcPts val="200"/>
+              </a:spcBef>
+              <a:defRPr sz="1400">
+                <a:solidFill>
+                  <a:srgbClr val="333333"/>
+                </a:solidFill>
+              </a:defRPr>
+            </a:pPr>
+            <a:r>
+              <a:rPr sz="1200" dirty="0"/>
+              <a:t>Configurable: local (127.0.0.1:8000) or remote (PythonAnywhere)</a:t>
+            </a:r>
+          </a:p>
+          <a:p>
+            <a:pPr>
+              <a:spcBef>
+                <a:spcPts val="200"/>
+              </a:spcBef>
+              <a:defRPr sz="1400">
+                <a:solidFill>
+                  <a:srgbClr val="333333"/>
+                </a:solidFill>
+              </a:defRPr>
+            </a:pPr>
+            <a:r>
+              <a:rPr sz="1200" dirty="0"/>
+              <a:t>Edge cases: duplicate registration, unauthorized access, future dates</a:t>
+            </a:r>
+          </a:p>
+        </p:txBody>
+      </p:sp>
+      <p:pic>
+        <p:nvPicPr>
+          <p:cNvPr id="13" name="图片 12">
+            <a:extLst>
+              <a:ext uri="{FF2B5EF4-FFF2-40B4-BE49-F238E27FC236}">
+                <a16:creationId xmlns:a16="http://schemas.microsoft.com/office/drawing/2014/main" id="{DFE0FFBD-3221-5160-4A1F-088973E74682}"/>
+              </a:ext>
+            </a:extLst>
+          </p:cNvPr>
+          <p:cNvPicPr>
+            <a:picLocks noChangeAspect="1"/>
+          </p:cNvPicPr>
+          <p:nvPr/>
+        </p:nvPicPr>
+        <p:blipFill>
+          <a:blip r:embed="rId3"/>
+          <a:stretch>
+            <a:fillRect/>
+          </a:stretch>
+        </p:blipFill>
+        <p:spPr>
+          <a:xfrm>
+            <a:off x="5392887" y="1038337"/>
+            <a:ext cx="3293913" cy="3614623"/>
+          </a:xfrm>
+          <a:prstGeom prst="rect">
+            <a:avLst/>
+          </a:prstGeom>
+        </p:spPr>
+      </p:pic>
+    </p:spTree>
+    <p:extLst>
+      <p:ext uri="{BB962C8B-B14F-4D97-AF65-F5344CB8AC3E}">
+        <p14:creationId xmlns:p14="http://schemas.microsoft.com/office/powerpoint/2010/main" val="3885338553"/>
+      </p:ext>
+    </p:extLst>
+  </p:cSld>
+  <p:clrMapOvr>
+    <a:masterClrMapping/>
+  </p:clrMapOvr>
+</p:sld>
+</file>
+
+<file path=ppt/slides/slide9.xml><?xml version="1.0" encoding="utf-8"?>
+<p:sld xmlns:a="http://schemas.openxmlformats.org/drawingml/2006/main" xmlns:r="http://schemas.openxmlformats.org/officeDocument/2006/relationships" xmlns:p="http://schemas.openxmlformats.org/presentationml/2006/main">
+  <p:cSld>
+    <p:spTree>
+      <p:nvGrpSpPr>
+        <p:cNvPr id="1" name="">
+          <a:extLst>
+            <a:ext uri="{FF2B5EF4-FFF2-40B4-BE49-F238E27FC236}">
+              <a16:creationId xmlns:a16="http://schemas.microsoft.com/office/drawing/2014/main" id="{9599E367-4701-B095-4927-3FF9EAB4A44B}"/>
+            </a:ext>
+          </a:extLst>
+        </p:cNvPr>
+        <p:cNvGrpSpPr/>
+        <p:nvPr/>
+      </p:nvGrpSpPr>
+      <p:grpSpPr>
+        <a:xfrm>
+          <a:off x="0" y="0"/>
+          <a:ext cx="0" cy="0"/>
+          <a:chOff x="0" y="0"/>
+          <a:chExt cx="0" cy="0"/>
+        </a:xfrm>
+      </p:grpSpPr>
+      <p:sp>
+        <p:nvSpPr>
+          <p:cNvPr id="2" name="Text 0">
+            <a:extLst>
+              <a:ext uri="{FF2B5EF4-FFF2-40B4-BE49-F238E27FC236}">
+                <a16:creationId xmlns:a16="http://schemas.microsoft.com/office/drawing/2014/main" id="{D781DB40-B023-443F-6F52-D30D51117CDD}"/>
+              </a:ext>
+            </a:extLst>
+          </p:cNvPr>
           <p:cNvSpPr/>
           <p:nvPr/>
         </p:nvSpPr>
         <p:spPr>
           <a:xfrm>
-            <a:off x="457200" y="822960"/>
-            <a:ext cx="8229600" cy="3108960"/>
+            <a:off x="457200" y="182880"/>
+            <a:ext cx="8229600" cy="471022"/>
           </a:xfrm>
           <a:prstGeom prst="rect">
             <a:avLst/>
@@ -4971,216 +6531,1185 @@
           <a:bodyPr wrap="square" rtlCol="0" anchor="ctr"/>
           <a:lstStyle/>
           <a:p>
-            <a:pPr marL="0" indent="0">
-              <a:buNone/>
-            </a:pPr>
-            <a:r>
-              <a:rPr lang="en-US" sz="2000" b="1" dirty="0">
-                <a:solidFill>
-                  <a:srgbClr val="FFFFFF"/>
-                </a:solidFill>
-                <a:latin typeface="Arial" pitchFamily="34" charset="0"/>
-                <a:ea typeface="Arial" pitchFamily="34" charset="-122"/>
-                <a:cs typeface="Arial" pitchFamily="34" charset="-120"/>
-              </a:rPr>
-              <a:t>1. Fully tested: </a:t>
-            </a:r>
-            <a:r>
-              <a:rPr lang="en-US" sz="2000" dirty="0">
-                <a:solidFill>
-                  <a:srgbClr val="FFFFFF"/>
-                </a:solidFill>
-                <a:latin typeface="Arial" pitchFamily="34" charset="0"/>
-                <a:ea typeface="Arial" pitchFamily="34" charset="-122"/>
-                <a:cs typeface="Arial" pitchFamily="34" charset="-120"/>
-              </a:rPr>
-              <a:t>28 integration tests across 5 modules — all passed against PythonAnywhere.</a:t>
-            </a:r>
-            <a:endParaRPr lang="en-US" sz="2000" dirty="0"/>
-          </a:p>
-          <a:p>
-            <a:pPr marL="0" indent="0">
-              <a:buNone/>
-            </a:pPr>
-            <a:endParaRPr lang="en-US" sz="2000" dirty="0"/>
-          </a:p>
-          <a:p>
-            <a:pPr marL="0" indent="0">
-              <a:buNone/>
-            </a:pPr>
-            <a:r>
-              <a:rPr lang="en-US" sz="2000" b="1" dirty="0">
-                <a:solidFill>
-                  <a:srgbClr val="FFFFFF"/>
-                </a:solidFill>
-                <a:latin typeface="Arial" pitchFamily="34" charset="0"/>
-                <a:ea typeface="Arial" pitchFamily="34" charset="-122"/>
-                <a:cs typeface="Arial" pitchFamily="34" charset="-120"/>
-              </a:rPr>
-              <a:t>2. Deployed: </a:t>
-            </a:r>
-            <a:r>
-              <a:rPr lang="en-US" sz="2000" dirty="0">
-                <a:solidFill>
-                  <a:srgbClr val="FFFFFF"/>
-                </a:solidFill>
-                <a:latin typeface="Arial" pitchFamily="34" charset="0"/>
-                <a:ea typeface="Arial" pitchFamily="34" charset="-122"/>
-                <a:cs typeface="Arial" pitchFamily="34" charset="-120"/>
-              </a:rPr>
-              <a:t>PythonAnywhere free tier with custom ASGI→WSGI bridge (3 iterations to solve).</a:t>
-            </a:r>
-            <a:endParaRPr lang="en-US" sz="2000" dirty="0"/>
-          </a:p>
-          <a:p>
-            <a:pPr marL="0" indent="0">
-              <a:buNone/>
-            </a:pPr>
-            <a:endParaRPr lang="en-US" sz="2000" dirty="0"/>
-          </a:p>
-          <a:p>
-            <a:pPr marL="0" indent="0">
-              <a:buNone/>
-            </a:pPr>
-            <a:r>
-              <a:rPr lang="en-US" sz="2000" b="1" dirty="0">
-                <a:solidFill>
-                  <a:srgbClr val="FFFFFF"/>
-                </a:solidFill>
-                <a:latin typeface="Arial" pitchFamily="34" charset="0"/>
-                <a:ea typeface="Arial" pitchFamily="34" charset="-122"/>
-                <a:cs typeface="Arial" pitchFamily="34" charset="-120"/>
-              </a:rPr>
-              <a:t>3. MCP-enabled: </a:t>
-            </a:r>
-            <a:r>
-              <a:rPr lang="en-US" sz="2000" dirty="0">
-                <a:solidFill>
-                  <a:srgbClr val="FFFFFF"/>
-                </a:solidFill>
-                <a:latin typeface="Arial" pitchFamily="34" charset="0"/>
-                <a:ea typeface="Arial" pitchFamily="34" charset="-122"/>
-                <a:cs typeface="Arial" pitchFamily="34" charset="-120"/>
-              </a:rPr>
-              <a:t>16 tools allow AI assistants to interact with the entire API via natural language.</a:t>
-            </a:r>
-            <a:endParaRPr lang="en-US" sz="2000" dirty="0"/>
-          </a:p>
-          <a:p>
-            <a:pPr marL="0" indent="0">
-              <a:buNone/>
-            </a:pPr>
-            <a:endParaRPr lang="en-US" sz="2000" dirty="0"/>
-          </a:p>
-          <a:p>
-            <a:pPr marL="0" indent="0">
-              <a:buNone/>
-            </a:pPr>
-            <a:r>
-              <a:rPr lang="en-US" sz="2000" b="1" dirty="0">
-                <a:solidFill>
-                  <a:srgbClr val="FFFFFF"/>
-                </a:solidFill>
-                <a:latin typeface="Arial" pitchFamily="34" charset="0"/>
-                <a:ea typeface="Arial" pitchFamily="34" charset="-122"/>
-                <a:cs typeface="Arial" pitchFamily="34" charset="-120"/>
-              </a:rPr>
-              <a:t>4. GenAI-assisted: </a:t>
-            </a:r>
-            <a:r>
-              <a:rPr lang="en-US" sz="2000" dirty="0">
-                <a:solidFill>
-                  <a:srgbClr val="FFFFFF"/>
-                </a:solidFill>
-                <a:latin typeface="Arial" pitchFamily="34" charset="0"/>
-                <a:ea typeface="Arial" pitchFamily="34" charset="-122"/>
-                <a:cs typeface="Arial" pitchFamily="34" charset="-120"/>
-              </a:rPr>
-              <a:t>GitHub Copilot + Claude Code (Opus 4.6) for planning, coding, debugging, and docs.</a:t>
-            </a:r>
-            <a:endParaRPr lang="en-US" sz="2000" dirty="0"/>
+            <a:pPr>
+              <a:defRPr sz="2800" b="1">
+                <a:solidFill>
+                  <a:srgbClr val="1A1A2E"/>
+                </a:solidFill>
+              </a:defRPr>
+            </a:pPr>
+            <a:r>
+              <a:rPr lang="en" altLang="zh-CN" sz="2400" b="1" dirty="0">
+                <a:solidFill>
+                  <a:srgbClr val="1F4E79"/>
+                </a:solidFill>
+                <a:latin typeface="Arial" pitchFamily="34" charset="0"/>
+                <a:cs typeface="Arial" pitchFamily="34" charset="-120"/>
+              </a:rPr>
+              <a:t>Links &amp; Deliverables</a:t>
+            </a:r>
           </a:p>
         </p:txBody>
       </p:sp>
       <p:sp>
         <p:nvSpPr>
-          <p:cNvPr id="5" name="Text 3"/>
+          <p:cNvPr id="3" name="Shape 1">
+            <a:extLst>
+              <a:ext uri="{FF2B5EF4-FFF2-40B4-BE49-F238E27FC236}">
+                <a16:creationId xmlns:a16="http://schemas.microsoft.com/office/drawing/2014/main" id="{77AD6A55-1238-10EC-3EB9-4B3B8773BD6A}"/>
+              </a:ext>
+            </a:extLst>
+          </p:cNvPr>
           <p:cNvSpPr/>
           <p:nvPr/>
         </p:nvSpPr>
         <p:spPr>
           <a:xfrm>
-            <a:off x="457200" y="4206240"/>
-            <a:ext cx="6400800" cy="274320"/>
+            <a:off x="457200" y="675169"/>
+            <a:ext cx="8229600" cy="22860"/>
           </a:xfrm>
           <a:prstGeom prst="rect">
             <a:avLst/>
           </a:prstGeom>
-          <a:noFill/>
+          <a:solidFill>
+            <a:srgbClr val="CCCCCC"/>
+          </a:solidFill>
           <a:ln/>
         </p:spPr>
         <p:txBody>
-          <a:bodyPr wrap="square" rtlCol="0" anchor="ctr"/>
+          <a:bodyPr/>
           <a:lstStyle/>
           <a:p>
-            <a:pPr marL="0" indent="0">
-              <a:buNone/>
-            </a:pPr>
-            <a:r>
-              <a:rPr lang="en-US" sz="1300" dirty="0">
-                <a:solidFill>
-                  <a:srgbClr val="A0BBDD"/>
-                </a:solidFill>
-                <a:latin typeface="Arial" pitchFamily="34" charset="0"/>
-                <a:ea typeface="Arial" pitchFamily="34" charset="-122"/>
-                <a:cs typeface="Arial" pitchFamily="34" charset="-120"/>
-              </a:rPr>
-              <a:t>Chenxi Li  ·  GitHub: github.com/lcx-0504/Web-Service-and-Data-CW1</a:t>
-            </a:r>
-            <a:endParaRPr lang="en-US" sz="1300" dirty="0"/>
+            <a:endParaRPr lang="zh-CN" altLang="en-US"/>
           </a:p>
         </p:txBody>
       </p:sp>
-      <p:sp>
-        <p:nvSpPr>
-          <p:cNvPr id="6" name="Text 4"/>
-          <p:cNvSpPr/>
-          <p:nvPr/>
-        </p:nvSpPr>
-        <p:spPr>
-          <a:xfrm>
-            <a:off x="457200" y="4572000"/>
-            <a:ext cx="8229600" cy="365760"/>
-          </a:xfrm>
-          <a:prstGeom prst="rect">
-            <a:avLst/>
-          </a:prstGeom>
-          <a:noFill/>
-          <a:ln/>
-        </p:spPr>
-        <p:txBody>
-          <a:bodyPr wrap="square" rtlCol="0" anchor="ctr"/>
-          <a:lstStyle/>
-          <a:p>
-            <a:pPr marL="0" indent="0">
-              <a:buNone/>
-            </a:pPr>
-            <a:r>
-              <a:rPr lang="en-US" sz="1800" b="1" dirty="0">
-                <a:solidFill>
-                  <a:srgbClr val="CADCFC"/>
-                </a:solidFill>
-                <a:latin typeface="Arial" pitchFamily="34" charset="0"/>
-                <a:ea typeface="Arial" pitchFamily="34" charset="-122"/>
-                <a:cs typeface="Arial" pitchFamily="34" charset="-120"/>
-              </a:rPr>
-              <a:t>Thank you — Questions?</a:t>
-            </a:r>
-            <a:endParaRPr lang="en-US" sz="1800" dirty="0"/>
-          </a:p>
-        </p:txBody>
-      </p:sp>
+      <p:graphicFrame>
+        <p:nvGraphicFramePr>
+          <p:cNvPr id="8" name="表格 7">
+            <a:extLst>
+              <a:ext uri="{FF2B5EF4-FFF2-40B4-BE49-F238E27FC236}">
+                <a16:creationId xmlns:a16="http://schemas.microsoft.com/office/drawing/2014/main" id="{E7A967DF-7A55-81D6-E3F1-B667BC20BFEA}"/>
+              </a:ext>
+            </a:extLst>
+          </p:cNvPr>
+          <p:cNvGraphicFramePr>
+            <a:graphicFrameLocks noGrp="1"/>
+          </p:cNvGraphicFramePr>
+          <p:nvPr>
+            <p:extLst>
+              <p:ext uri="{D42A27DB-BD31-4B8C-83A1-F6EECF244321}">
+                <p14:modId xmlns:p14="http://schemas.microsoft.com/office/powerpoint/2010/main" val="2424195262"/>
+              </p:ext>
+            </p:extLst>
+          </p:nvPr>
+        </p:nvGraphicFramePr>
+        <p:xfrm>
+          <a:off x="457199" y="814984"/>
+          <a:ext cx="8229600" cy="4053127"/>
+        </p:xfrm>
+        <a:graphic>
+          <a:graphicData uri="http://schemas.openxmlformats.org/drawingml/2006/table">
+            <a:tbl>
+              <a:tblPr firstRow="1" bandRow="1">
+                <a:tableStyleId>{7DF18680-E054-41AD-8BC1-D1AEF772440D}</a:tableStyleId>
+              </a:tblPr>
+              <a:tblGrid>
+                <a:gridCol w="2270052">
+                  <a:extLst>
+                    <a:ext uri="{9D8B030D-6E8A-4147-A177-3AD203B41FA5}">
+                      <a16:colId xmlns:a16="http://schemas.microsoft.com/office/drawing/2014/main" val="687018504"/>
+                    </a:ext>
+                  </a:extLst>
+                </a:gridCol>
+                <a:gridCol w="5959548">
+                  <a:extLst>
+                    <a:ext uri="{9D8B030D-6E8A-4147-A177-3AD203B41FA5}">
+                      <a16:colId xmlns:a16="http://schemas.microsoft.com/office/drawing/2014/main" val="4173297094"/>
+                    </a:ext>
+                  </a:extLst>
+                </a:gridCol>
+              </a:tblGrid>
+              <a:tr h="311779">
+                <a:tc>
+                  <a:txBody>
+                    <a:bodyPr/>
+                    <a:lstStyle/>
+                    <a:p>
+                      <a:pPr algn="ctr" fontAlgn="ctr">
+                        <a:buNone/>
+                      </a:pPr>
+                      <a:r>
+                        <a:rPr lang="en" sz="1000" u="none" strike="noStrike" dirty="0">
+                          <a:effectLst/>
+                        </a:rPr>
+                        <a:t>Deliverable</a:t>
+                      </a:r>
+                      <a:endParaRPr lang="en" sz="1000" b="0" i="0" u="none" strike="noStrike" dirty="0">
+                        <a:solidFill>
+                          <a:srgbClr val="000000"/>
+                        </a:solidFill>
+                        <a:effectLst/>
+                        <a:latin typeface="等线" panose="02010600030101010101" pitchFamily="2" charset="-122"/>
+                        <a:ea typeface="等线" panose="02010600030101010101" pitchFamily="2" charset="-122"/>
+                      </a:endParaRPr>
+                    </a:p>
+                  </a:txBody>
+                  <a:tcPr marL="4747" marR="4747" marT="4747" marB="0" anchor="ctr"/>
+                </a:tc>
+                <a:tc>
+                  <a:txBody>
+                    <a:bodyPr/>
+                    <a:lstStyle/>
+                    <a:p>
+                      <a:pPr algn="ctr" fontAlgn="ctr">
+                        <a:buNone/>
+                      </a:pPr>
+                      <a:r>
+                        <a:rPr lang="en" sz="1000" u="none" strike="noStrike">
+                          <a:effectLst/>
+                        </a:rPr>
+                        <a:t>Link / Location</a:t>
+                      </a:r>
+                      <a:endParaRPr lang="en" sz="1000" b="0" i="0" u="none" strike="noStrike">
+                        <a:solidFill>
+                          <a:srgbClr val="000000"/>
+                        </a:solidFill>
+                        <a:effectLst/>
+                        <a:latin typeface="等线" panose="02010600030101010101" pitchFamily="2" charset="-122"/>
+                        <a:ea typeface="等线" panose="02010600030101010101" pitchFamily="2" charset="-122"/>
+                      </a:endParaRPr>
+                    </a:p>
+                  </a:txBody>
+                  <a:tcPr marL="4747" marR="4747" marT="4747" marB="0" anchor="ctr"/>
+                </a:tc>
+                <a:extLst>
+                  <a:ext uri="{0D108BD9-81ED-4DB2-BD59-A6C34878D82A}">
+                    <a16:rowId xmlns:a16="http://schemas.microsoft.com/office/drawing/2014/main" val="2308007352"/>
+                  </a:ext>
+                </a:extLst>
+              </a:tr>
+              <a:tr h="311779">
+                <a:tc>
+                  <a:txBody>
+                    <a:bodyPr/>
+                    <a:lstStyle/>
+                    <a:p>
+                      <a:pPr algn="ctr" fontAlgn="ctr">
+                        <a:buNone/>
+                      </a:pPr>
+                      <a:r>
+                        <a:rPr lang="en" sz="1000" u="none" strike="noStrike" dirty="0">
+                          <a:effectLst/>
+                        </a:rPr>
+                        <a:t>Code Repository</a:t>
+                      </a:r>
+                      <a:endParaRPr lang="en" sz="1000" b="0" i="0" u="none" strike="noStrike" dirty="0">
+                        <a:solidFill>
+                          <a:srgbClr val="000000"/>
+                        </a:solidFill>
+                        <a:effectLst/>
+                        <a:latin typeface="等线" panose="02010600030101010101" pitchFamily="2" charset="-122"/>
+                        <a:ea typeface="等线" panose="02010600030101010101" pitchFamily="2" charset="-122"/>
+                      </a:endParaRPr>
+                    </a:p>
+                  </a:txBody>
+                  <a:tcPr marL="4747" marR="4747" marT="4747" marB="0" anchor="ctr"/>
+                </a:tc>
+                <a:tc>
+                  <a:txBody>
+                    <a:bodyPr/>
+                    <a:lstStyle/>
+                    <a:p>
+                      <a:pPr algn="ctr" fontAlgn="ctr">
+                        <a:buNone/>
+                      </a:pPr>
+                      <a:r>
+                        <a:rPr lang="en" sz="1000" u="none" strike="noStrike" dirty="0">
+                          <a:effectLst/>
+                          <a:hlinkClick r:id="rId3"/>
+                        </a:rPr>
+                        <a:t>https://</a:t>
+                      </a:r>
+                      <a:r>
+                        <a:rPr lang="en" sz="1000" u="none" strike="noStrike" dirty="0" err="1">
+                          <a:effectLst/>
+                          <a:hlinkClick r:id="rId3"/>
+                        </a:rPr>
+                        <a:t>github.com</a:t>
+                      </a:r>
+                      <a:r>
+                        <a:rPr lang="en" sz="1000" u="none" strike="noStrike" dirty="0">
+                          <a:effectLst/>
+                          <a:hlinkClick r:id="rId3"/>
+                        </a:rPr>
+                        <a:t>/lcx-0504/Web-Service-and-Data-CW1</a:t>
+                      </a:r>
+                      <a:endParaRPr lang="en" sz="1000" b="0" i="0" u="none" strike="noStrike" dirty="0">
+                        <a:solidFill>
+                          <a:srgbClr val="000000"/>
+                        </a:solidFill>
+                        <a:effectLst/>
+                        <a:latin typeface="等线" panose="02010600030101010101" pitchFamily="2" charset="-122"/>
+                        <a:ea typeface="等线" panose="02010600030101010101" pitchFamily="2" charset="-122"/>
+                      </a:endParaRPr>
+                    </a:p>
+                  </a:txBody>
+                  <a:tcPr marL="4747" marR="4747" marT="4747" marB="0" anchor="ctr"/>
+                </a:tc>
+                <a:extLst>
+                  <a:ext uri="{0D108BD9-81ED-4DB2-BD59-A6C34878D82A}">
+                    <a16:rowId xmlns:a16="http://schemas.microsoft.com/office/drawing/2014/main" val="364178044"/>
+                  </a:ext>
+                </a:extLst>
+              </a:tr>
+              <a:tr h="311779">
+                <a:tc>
+                  <a:txBody>
+                    <a:bodyPr/>
+                    <a:lstStyle/>
+                    <a:p>
+                      <a:pPr algn="ctr" fontAlgn="ctr">
+                        <a:buNone/>
+                      </a:pPr>
+                      <a:r>
+                        <a:rPr lang="en" sz="1000" u="none" strike="noStrike" dirty="0">
+                          <a:effectLst/>
+                        </a:rPr>
+                        <a:t>Commit History</a:t>
+                      </a:r>
+                      <a:r>
+                        <a:rPr lang="zh-CN" altLang="en-US" sz="1000" u="none" strike="noStrike" dirty="0">
+                          <a:effectLst/>
+                        </a:rPr>
+                        <a:t> </a:t>
+                      </a:r>
+                      <a:r>
+                        <a:rPr lang="en-US" altLang="zh-CN" sz="1000" u="none" strike="noStrike" dirty="0">
+                          <a:effectLst/>
+                        </a:rPr>
+                        <a:t>(16 </a:t>
+                      </a:r>
+                      <a:r>
+                        <a:rPr lang="en" altLang="zh-CN" sz="1000" u="none" strike="noStrike" dirty="0">
+                          <a:effectLst/>
+                        </a:rPr>
+                        <a:t>commits)</a:t>
+                      </a:r>
+                      <a:endParaRPr lang="en" sz="1000" b="0" i="0" u="none" strike="noStrike" dirty="0">
+                        <a:solidFill>
+                          <a:srgbClr val="000000"/>
+                        </a:solidFill>
+                        <a:effectLst/>
+                        <a:latin typeface="等线" panose="02010600030101010101" pitchFamily="2" charset="-122"/>
+                        <a:ea typeface="等线" panose="02010600030101010101" pitchFamily="2" charset="-122"/>
+                      </a:endParaRPr>
+                    </a:p>
+                  </a:txBody>
+                  <a:tcPr marL="4747" marR="4747" marT="4747" marB="0" anchor="ctr"/>
+                </a:tc>
+                <a:tc>
+                  <a:txBody>
+                    <a:bodyPr/>
+                    <a:lstStyle/>
+                    <a:p>
+                      <a:pPr algn="ctr" fontAlgn="ctr">
+                        <a:buNone/>
+                      </a:pPr>
+                      <a:r>
+                        <a:rPr lang="en" sz="1000" u="none" strike="noStrike" dirty="0">
+                          <a:effectLst/>
+                          <a:hlinkClick r:id="rId4"/>
+                        </a:rPr>
+                        <a:t>https://</a:t>
+                      </a:r>
+                      <a:r>
+                        <a:rPr lang="en" sz="1000" u="none" strike="noStrike" dirty="0" err="1">
+                          <a:effectLst/>
+                          <a:hlinkClick r:id="rId4"/>
+                        </a:rPr>
+                        <a:t>github.com</a:t>
+                      </a:r>
+                      <a:r>
+                        <a:rPr lang="en" sz="1000" u="none" strike="noStrike" dirty="0">
+                          <a:effectLst/>
+                          <a:hlinkClick r:id="rId4"/>
+                        </a:rPr>
+                        <a:t>/lcx-0504/Web-Service-and-Data-CW1/commits/main</a:t>
+                      </a:r>
+                      <a:endParaRPr lang="en" sz="1000" b="0" i="0" u="none" strike="noStrike" dirty="0">
+                        <a:solidFill>
+                          <a:srgbClr val="000000"/>
+                        </a:solidFill>
+                        <a:effectLst/>
+                        <a:latin typeface="等线" panose="02010600030101010101" pitchFamily="2" charset="-122"/>
+                        <a:ea typeface="等线" panose="02010600030101010101" pitchFamily="2" charset="-122"/>
+                      </a:endParaRPr>
+                    </a:p>
+                  </a:txBody>
+                  <a:tcPr marL="4747" marR="4747" marT="4747" marB="0" anchor="ctr"/>
+                </a:tc>
+                <a:extLst>
+                  <a:ext uri="{0D108BD9-81ED-4DB2-BD59-A6C34878D82A}">
+                    <a16:rowId xmlns:a16="http://schemas.microsoft.com/office/drawing/2014/main" val="1232171003"/>
+                  </a:ext>
+                </a:extLst>
+              </a:tr>
+              <a:tr h="311779">
+                <a:tc>
+                  <a:txBody>
+                    <a:bodyPr/>
+                    <a:lstStyle/>
+                    <a:p>
+                      <a:pPr algn="ctr" fontAlgn="ctr">
+                        <a:buNone/>
+                      </a:pPr>
+                      <a:r>
+                        <a:rPr lang="en" sz="1000" u="none" strike="noStrike" dirty="0">
+                          <a:effectLst/>
+                        </a:rPr>
+                        <a:t>Live API (</a:t>
+                      </a:r>
+                      <a:r>
+                        <a:rPr lang="en" altLang="zh-CN" sz="1000" u="none" strike="noStrike" dirty="0">
+                          <a:effectLst/>
+                        </a:rPr>
+                        <a:t>Deployed on PythonAnywhere)</a:t>
+                      </a:r>
+                      <a:endParaRPr lang="en" sz="1000" b="0" i="0" u="none" strike="noStrike" dirty="0">
+                        <a:solidFill>
+                          <a:srgbClr val="000000"/>
+                        </a:solidFill>
+                        <a:effectLst/>
+                        <a:latin typeface="等线" panose="02010600030101010101" pitchFamily="2" charset="-122"/>
+                        <a:ea typeface="等线" panose="02010600030101010101" pitchFamily="2" charset="-122"/>
+                      </a:endParaRPr>
+                    </a:p>
+                  </a:txBody>
+                  <a:tcPr marL="4747" marR="4747" marT="4747" marB="0" anchor="ctr"/>
+                </a:tc>
+                <a:tc>
+                  <a:txBody>
+                    <a:bodyPr/>
+                    <a:lstStyle/>
+                    <a:p>
+                      <a:pPr algn="ctr" fontAlgn="ctr">
+                        <a:buNone/>
+                      </a:pPr>
+                      <a:r>
+                        <a:rPr lang="en" sz="1000" u="none" strike="noStrike" dirty="0">
+                          <a:effectLst/>
+                          <a:hlinkClick r:id="rId5"/>
+                        </a:rPr>
+                        <a:t>https://lichenxi.pythonanywhere.com/</a:t>
+                      </a:r>
+                      <a:endParaRPr lang="en" sz="1000" b="0" i="0" u="none" strike="noStrike" dirty="0">
+                        <a:solidFill>
+                          <a:srgbClr val="000000"/>
+                        </a:solidFill>
+                        <a:effectLst/>
+                        <a:latin typeface="等线" panose="02010600030101010101" pitchFamily="2" charset="-122"/>
+                        <a:ea typeface="等线" panose="02010600030101010101" pitchFamily="2" charset="-122"/>
+                      </a:endParaRPr>
+                    </a:p>
+                  </a:txBody>
+                  <a:tcPr marL="4747" marR="4747" marT="4747" marB="0" anchor="ctr"/>
+                </a:tc>
+                <a:extLst>
+                  <a:ext uri="{0D108BD9-81ED-4DB2-BD59-A6C34878D82A}">
+                    <a16:rowId xmlns:a16="http://schemas.microsoft.com/office/drawing/2014/main" val="3082461793"/>
+                  </a:ext>
+                </a:extLst>
+              </a:tr>
+              <a:tr h="311779">
+                <a:tc>
+                  <a:txBody>
+                    <a:bodyPr/>
+                    <a:lstStyle/>
+                    <a:p>
+                      <a:pPr algn="ctr" fontAlgn="ctr">
+                        <a:buNone/>
+                      </a:pPr>
+                      <a:r>
+                        <a:rPr lang="en" sz="1000" u="none" strike="noStrike">
+                          <a:effectLst/>
+                        </a:rPr>
+                        <a:t>Swagger UI</a:t>
+                      </a:r>
+                      <a:endParaRPr lang="en" sz="1000" b="0" i="0" u="none" strike="noStrike">
+                        <a:solidFill>
+                          <a:srgbClr val="000000"/>
+                        </a:solidFill>
+                        <a:effectLst/>
+                        <a:latin typeface="等线" panose="02010600030101010101" pitchFamily="2" charset="-122"/>
+                        <a:ea typeface="等线" panose="02010600030101010101" pitchFamily="2" charset="-122"/>
+                      </a:endParaRPr>
+                    </a:p>
+                  </a:txBody>
+                  <a:tcPr marL="4747" marR="4747" marT="4747" marB="0" anchor="ctr"/>
+                </a:tc>
+                <a:tc>
+                  <a:txBody>
+                    <a:bodyPr/>
+                    <a:lstStyle/>
+                    <a:p>
+                      <a:pPr marL="0" marR="0" lvl="0" indent="0" algn="ctr" defTabSz="914400" rtl="0" eaLnBrk="1" fontAlgn="ctr" latinLnBrk="0" hangingPunct="1">
+                        <a:lnSpc>
+                          <a:spcPct val="100000"/>
+                        </a:lnSpc>
+                        <a:spcBef>
+                          <a:spcPts val="0"/>
+                        </a:spcBef>
+                        <a:spcAft>
+                          <a:spcPts val="0"/>
+                        </a:spcAft>
+                        <a:buClrTx/>
+                        <a:buSzTx/>
+                        <a:buFontTx/>
+                        <a:buNone/>
+                        <a:tabLst/>
+                        <a:defRPr/>
+                      </a:pPr>
+                      <a:r>
+                        <a:rPr lang="en" altLang="zh-CN" sz="1000" u="none" strike="noStrike" dirty="0">
+                          <a:effectLst/>
+                          <a:hlinkClick r:id="rId6"/>
+                        </a:rPr>
+                        <a:t>https://lichenxi.pythonanywhere.com</a:t>
+                      </a:r>
+                      <a:r>
+                        <a:rPr lang="en" sz="1000" u="none" strike="noStrike" dirty="0">
+                          <a:effectLst/>
+                          <a:hlinkClick r:id="rId6"/>
+                        </a:rPr>
+                        <a:t>/docs</a:t>
+                      </a:r>
+                      <a:endParaRPr lang="en" sz="1000" b="0" i="0" u="none" strike="noStrike" dirty="0">
+                        <a:solidFill>
+                          <a:srgbClr val="000000"/>
+                        </a:solidFill>
+                        <a:effectLst/>
+                        <a:latin typeface="等线" panose="02010600030101010101" pitchFamily="2" charset="-122"/>
+                        <a:ea typeface="等线" panose="02010600030101010101" pitchFamily="2" charset="-122"/>
+                      </a:endParaRPr>
+                    </a:p>
+                  </a:txBody>
+                  <a:tcPr marL="4747" marR="4747" marT="4747" marB="0" anchor="ctr"/>
+                </a:tc>
+                <a:extLst>
+                  <a:ext uri="{0D108BD9-81ED-4DB2-BD59-A6C34878D82A}">
+                    <a16:rowId xmlns:a16="http://schemas.microsoft.com/office/drawing/2014/main" val="101807880"/>
+                  </a:ext>
+                </a:extLst>
+              </a:tr>
+              <a:tr h="311779">
+                <a:tc>
+                  <a:txBody>
+                    <a:bodyPr/>
+                    <a:lstStyle/>
+                    <a:p>
+                      <a:pPr algn="ctr" fontAlgn="ctr">
+                        <a:buNone/>
+                      </a:pPr>
+                      <a:r>
+                        <a:rPr lang="en" sz="1000" u="none" strike="noStrike" dirty="0" err="1">
+                          <a:effectLst/>
+                        </a:rPr>
+                        <a:t>ReDoc</a:t>
+                      </a:r>
+                      <a:endParaRPr lang="en" sz="1000" b="0" i="0" u="none" strike="noStrike" dirty="0">
+                        <a:solidFill>
+                          <a:srgbClr val="000000"/>
+                        </a:solidFill>
+                        <a:effectLst/>
+                        <a:latin typeface="等线" panose="02010600030101010101" pitchFamily="2" charset="-122"/>
+                        <a:ea typeface="等线" panose="02010600030101010101" pitchFamily="2" charset="-122"/>
+                      </a:endParaRPr>
+                    </a:p>
+                  </a:txBody>
+                  <a:tcPr marL="4747" marR="4747" marT="4747" marB="0" anchor="ctr"/>
+                </a:tc>
+                <a:tc>
+                  <a:txBody>
+                    <a:bodyPr/>
+                    <a:lstStyle/>
+                    <a:p>
+                      <a:pPr marL="0" marR="0" lvl="0" indent="0" algn="ctr" defTabSz="914400" rtl="0" eaLnBrk="1" fontAlgn="ctr" latinLnBrk="0" hangingPunct="1">
+                        <a:lnSpc>
+                          <a:spcPct val="100000"/>
+                        </a:lnSpc>
+                        <a:spcBef>
+                          <a:spcPts val="0"/>
+                        </a:spcBef>
+                        <a:spcAft>
+                          <a:spcPts val="0"/>
+                        </a:spcAft>
+                        <a:buClrTx/>
+                        <a:buSzTx/>
+                        <a:buFontTx/>
+                        <a:buNone/>
+                        <a:tabLst/>
+                        <a:defRPr/>
+                      </a:pPr>
+                      <a:r>
+                        <a:rPr lang="en" altLang="zh-CN" sz="1000" u="none" strike="noStrike" dirty="0">
+                          <a:effectLst/>
+                          <a:hlinkClick r:id="rId7"/>
+                        </a:rPr>
+                        <a:t>https://lichenxi.pythonanywhere.com/redoc</a:t>
+                      </a:r>
+                      <a:endParaRPr lang="en" altLang="zh-CN" sz="1000" b="0" i="0" u="none" strike="noStrike" dirty="0">
+                        <a:solidFill>
+                          <a:srgbClr val="000000"/>
+                        </a:solidFill>
+                        <a:effectLst/>
+                        <a:latin typeface="等线" panose="02010600030101010101" pitchFamily="2" charset="-122"/>
+                        <a:ea typeface="+mn-ea"/>
+                      </a:endParaRPr>
+                    </a:p>
+                  </a:txBody>
+                  <a:tcPr marL="4747" marR="4747" marT="4747" marB="0" anchor="ctr"/>
+                </a:tc>
+                <a:extLst>
+                  <a:ext uri="{0D108BD9-81ED-4DB2-BD59-A6C34878D82A}">
+                    <a16:rowId xmlns:a16="http://schemas.microsoft.com/office/drawing/2014/main" val="2856072526"/>
+                  </a:ext>
+                </a:extLst>
+              </a:tr>
+              <a:tr h="311779">
+                <a:tc>
+                  <a:txBody>
+                    <a:bodyPr/>
+                    <a:lstStyle/>
+                    <a:p>
+                      <a:pPr algn="ctr" fontAlgn="ctr">
+                        <a:buNone/>
+                      </a:pPr>
+                      <a:r>
+                        <a:rPr lang="en" sz="1000" u="none" strike="noStrike" dirty="0">
+                          <a:effectLst/>
+                        </a:rPr>
+                        <a:t>API Documentation (PDF – 17 Endpoints)</a:t>
+                      </a:r>
+                      <a:endParaRPr lang="en" sz="1000" b="0" i="0" u="none" strike="noStrike" dirty="0">
+                        <a:solidFill>
+                          <a:srgbClr val="000000"/>
+                        </a:solidFill>
+                        <a:effectLst/>
+                        <a:latin typeface="等线" panose="02010600030101010101" pitchFamily="2" charset="-122"/>
+                        <a:ea typeface="等线" panose="02010600030101010101" pitchFamily="2" charset="-122"/>
+                      </a:endParaRPr>
+                    </a:p>
+                  </a:txBody>
+                  <a:tcPr marL="4747" marR="4747" marT="4747" marB="0" anchor="ctr"/>
+                </a:tc>
+                <a:tc>
+                  <a:txBody>
+                    <a:bodyPr/>
+                    <a:lstStyle/>
+                    <a:p>
+                      <a:pPr algn="ctr" fontAlgn="ctr">
+                        <a:buNone/>
+                      </a:pPr>
+                      <a:r>
+                        <a:rPr lang="en" sz="1000" u="none" strike="noStrike" dirty="0">
+                          <a:effectLst/>
+                          <a:hlinkClick r:id="rId8"/>
+                        </a:rPr>
+                        <a:t>https://</a:t>
+                      </a:r>
+                      <a:r>
+                        <a:rPr lang="en" sz="1000" u="none" strike="noStrike" dirty="0" err="1">
+                          <a:effectLst/>
+                          <a:hlinkClick r:id="rId8"/>
+                        </a:rPr>
+                        <a:t>github.com</a:t>
+                      </a:r>
+                      <a:r>
+                        <a:rPr lang="en" sz="1000" u="none" strike="noStrike" dirty="0">
+                          <a:effectLst/>
+                          <a:hlinkClick r:id="rId8"/>
+                        </a:rPr>
+                        <a:t>/lcx-0504/Web-Service-and-Data-CW1/blob/main/docs/</a:t>
+                      </a:r>
+                      <a:r>
+                        <a:rPr lang="en" sz="1000" u="none" strike="noStrike" dirty="0" err="1">
+                          <a:effectLst/>
+                          <a:hlinkClick r:id="rId8"/>
+                        </a:rPr>
+                        <a:t>api-documentation.pdf</a:t>
+                      </a:r>
+                      <a:endParaRPr lang="en" sz="1000" b="0" i="0" u="none" strike="noStrike" dirty="0">
+                        <a:solidFill>
+                          <a:srgbClr val="000000"/>
+                        </a:solidFill>
+                        <a:effectLst/>
+                        <a:latin typeface="等线" panose="02010600030101010101" pitchFamily="2" charset="-122"/>
+                        <a:ea typeface="等线" panose="02010600030101010101" pitchFamily="2" charset="-122"/>
+                      </a:endParaRPr>
+                    </a:p>
+                  </a:txBody>
+                  <a:tcPr marL="4747" marR="4747" marT="4747" marB="0" anchor="ctr"/>
+                </a:tc>
+                <a:extLst>
+                  <a:ext uri="{0D108BD9-81ED-4DB2-BD59-A6C34878D82A}">
+                    <a16:rowId xmlns:a16="http://schemas.microsoft.com/office/drawing/2014/main" val="2020361976"/>
+                  </a:ext>
+                </a:extLst>
+              </a:tr>
+              <a:tr h="311779">
+                <a:tc>
+                  <a:txBody>
+                    <a:bodyPr/>
+                    <a:lstStyle/>
+                    <a:p>
+                      <a:pPr algn="ctr" fontAlgn="ctr">
+                        <a:buNone/>
+                      </a:pPr>
+                      <a:r>
+                        <a:rPr lang="en" sz="1000" u="none" strike="noStrike" dirty="0">
+                          <a:effectLst/>
+                        </a:rPr>
+                        <a:t>Technical Report (PDF)</a:t>
+                      </a:r>
+                      <a:endParaRPr lang="en" sz="1000" b="0" i="0" u="none" strike="noStrike" dirty="0">
+                        <a:solidFill>
+                          <a:srgbClr val="000000"/>
+                        </a:solidFill>
+                        <a:effectLst/>
+                        <a:latin typeface="等线" panose="02010600030101010101" pitchFamily="2" charset="-122"/>
+                        <a:ea typeface="等线" panose="02010600030101010101" pitchFamily="2" charset="-122"/>
+                      </a:endParaRPr>
+                    </a:p>
+                  </a:txBody>
+                  <a:tcPr marL="4747" marR="4747" marT="4747" marB="0" anchor="ctr"/>
+                </a:tc>
+                <a:tc>
+                  <a:txBody>
+                    <a:bodyPr/>
+                    <a:lstStyle/>
+                    <a:p>
+                      <a:pPr algn="ctr" fontAlgn="ctr">
+                        <a:buNone/>
+                      </a:pPr>
+                      <a:r>
+                        <a:rPr lang="en" sz="1000" u="none" strike="noStrike" dirty="0">
+                          <a:effectLst/>
+                          <a:hlinkClick r:id="rId9"/>
+                        </a:rPr>
+                        <a:t>https://</a:t>
+                      </a:r>
+                      <a:r>
+                        <a:rPr lang="en" sz="1000" u="none" strike="noStrike" dirty="0" err="1">
+                          <a:effectLst/>
+                          <a:hlinkClick r:id="rId9"/>
+                        </a:rPr>
+                        <a:t>github.com</a:t>
+                      </a:r>
+                      <a:r>
+                        <a:rPr lang="en" sz="1000" u="none" strike="noStrike" dirty="0">
+                          <a:effectLst/>
+                          <a:hlinkClick r:id="rId9"/>
+                        </a:rPr>
+                        <a:t>/lcx-0504/Web-Service-and-Data-CW1/blob/main/docs/technical-</a:t>
+                      </a:r>
+                      <a:r>
+                        <a:rPr lang="en" sz="1000" u="none" strike="noStrike" dirty="0" err="1">
+                          <a:effectLst/>
+                          <a:hlinkClick r:id="rId9"/>
+                        </a:rPr>
+                        <a:t>report.pdf</a:t>
+                      </a:r>
+                      <a:endParaRPr lang="en" sz="1000" b="0" i="0" u="none" strike="noStrike" dirty="0">
+                        <a:solidFill>
+                          <a:srgbClr val="000000"/>
+                        </a:solidFill>
+                        <a:effectLst/>
+                        <a:latin typeface="等线" panose="02010600030101010101" pitchFamily="2" charset="-122"/>
+                        <a:ea typeface="等线" panose="02010600030101010101" pitchFamily="2" charset="-122"/>
+                      </a:endParaRPr>
+                    </a:p>
+                  </a:txBody>
+                  <a:tcPr marL="4747" marR="4747" marT="4747" marB="0" anchor="ctr"/>
+                </a:tc>
+                <a:extLst>
+                  <a:ext uri="{0D108BD9-81ED-4DB2-BD59-A6C34878D82A}">
+                    <a16:rowId xmlns:a16="http://schemas.microsoft.com/office/drawing/2014/main" val="484170766"/>
+                  </a:ext>
+                </a:extLst>
+              </a:tr>
+              <a:tr h="311779">
+                <a:tc>
+                  <a:txBody>
+                    <a:bodyPr/>
+                    <a:lstStyle/>
+                    <a:p>
+                      <a:pPr algn="ctr" fontAlgn="ctr">
+                        <a:buNone/>
+                      </a:pPr>
+                      <a:r>
+                        <a:rPr lang="en" sz="1000" u="none" strike="noStrike" dirty="0">
+                          <a:effectLst/>
+                        </a:rPr>
+                        <a:t>Presentation (PPTX)</a:t>
+                      </a:r>
+                      <a:endParaRPr lang="en" sz="1000" b="0" i="0" u="none" strike="noStrike" dirty="0">
+                        <a:solidFill>
+                          <a:srgbClr val="000000"/>
+                        </a:solidFill>
+                        <a:effectLst/>
+                        <a:latin typeface="等线" panose="02010600030101010101" pitchFamily="2" charset="-122"/>
+                        <a:ea typeface="等线" panose="02010600030101010101" pitchFamily="2" charset="-122"/>
+                      </a:endParaRPr>
+                    </a:p>
+                  </a:txBody>
+                  <a:tcPr marL="4747" marR="4747" marT="4747" marB="0" anchor="ctr"/>
+                </a:tc>
+                <a:tc>
+                  <a:txBody>
+                    <a:bodyPr/>
+                    <a:lstStyle/>
+                    <a:p>
+                      <a:pPr algn="ctr" fontAlgn="ctr">
+                        <a:buNone/>
+                      </a:pPr>
+                      <a:r>
+                        <a:rPr lang="en" sz="1000" u="none" strike="noStrike" dirty="0">
+                          <a:effectLst/>
+                          <a:hlinkClick r:id="rId10"/>
+                        </a:rPr>
+                        <a:t>https://</a:t>
+                      </a:r>
+                      <a:r>
+                        <a:rPr lang="en" sz="1000" u="none" strike="noStrike" dirty="0" err="1">
+                          <a:effectLst/>
+                          <a:hlinkClick r:id="rId10"/>
+                        </a:rPr>
+                        <a:t>github.com</a:t>
+                      </a:r>
+                      <a:r>
+                        <a:rPr lang="en" sz="1000" u="none" strike="noStrike" dirty="0">
+                          <a:effectLst/>
+                          <a:hlinkClick r:id="rId10"/>
+                        </a:rPr>
+                        <a:t>/lcx-0504/Web-Service-and-Data-CW1/blob/main/docs/</a:t>
+                      </a:r>
+                      <a:r>
+                        <a:rPr lang="en" sz="1000" u="none" strike="noStrike" dirty="0" err="1">
+                          <a:effectLst/>
+                          <a:hlinkClick r:id="rId10"/>
+                        </a:rPr>
+                        <a:t>presentation.pdf</a:t>
+                      </a:r>
+                      <a:endParaRPr lang="en" sz="1000" b="0" i="0" u="none" strike="noStrike" dirty="0">
+                        <a:solidFill>
+                          <a:srgbClr val="000000"/>
+                        </a:solidFill>
+                        <a:effectLst/>
+                        <a:latin typeface="等线" panose="02010600030101010101" pitchFamily="2" charset="-122"/>
+                        <a:ea typeface="等线" panose="02010600030101010101" pitchFamily="2" charset="-122"/>
+                      </a:endParaRPr>
+                    </a:p>
+                  </a:txBody>
+                  <a:tcPr marL="4747" marR="4747" marT="4747" marB="0" anchor="ctr"/>
+                </a:tc>
+                <a:extLst>
+                  <a:ext uri="{0D108BD9-81ED-4DB2-BD59-A6C34878D82A}">
+                    <a16:rowId xmlns:a16="http://schemas.microsoft.com/office/drawing/2014/main" val="1647138704"/>
+                  </a:ext>
+                </a:extLst>
+              </a:tr>
+              <a:tr h="311779">
+                <a:tc>
+                  <a:txBody>
+                    <a:bodyPr/>
+                    <a:lstStyle/>
+                    <a:p>
+                      <a:pPr algn="ctr" fontAlgn="ctr">
+                        <a:buNone/>
+                      </a:pPr>
+                      <a:r>
+                        <a:rPr lang="en" sz="1000" u="none" strike="noStrike" dirty="0">
+                          <a:effectLst/>
+                        </a:rPr>
+                        <a:t>GenAI Logs (Claude Code &amp;</a:t>
+                      </a:r>
+                    </a:p>
+                    <a:p>
+                      <a:pPr algn="ctr" fontAlgn="ctr">
+                        <a:buNone/>
+                      </a:pPr>
+                      <a:r>
+                        <a:rPr lang="en" sz="1000" u="none" strike="noStrike" dirty="0" err="1">
+                          <a:effectLst/>
+                        </a:rPr>
+                        <a:t>Github</a:t>
+                      </a:r>
+                      <a:r>
+                        <a:rPr lang="en" sz="1000" u="none" strike="noStrike" dirty="0">
+                          <a:effectLst/>
+                        </a:rPr>
+                        <a:t> Copilot with Claude Opus 4.6)</a:t>
+                      </a:r>
+                      <a:endParaRPr lang="en" sz="1000" b="0" i="0" u="none" strike="noStrike" dirty="0">
+                        <a:solidFill>
+                          <a:srgbClr val="000000"/>
+                        </a:solidFill>
+                        <a:effectLst/>
+                        <a:latin typeface="等线" panose="02010600030101010101" pitchFamily="2" charset="-122"/>
+                        <a:ea typeface="等线" panose="02010600030101010101" pitchFamily="2" charset="-122"/>
+                      </a:endParaRPr>
+                    </a:p>
+                  </a:txBody>
+                  <a:tcPr marL="4747" marR="4747" marT="4747" marB="0" anchor="ctr"/>
+                </a:tc>
+                <a:tc>
+                  <a:txBody>
+                    <a:bodyPr/>
+                    <a:lstStyle/>
+                    <a:p>
+                      <a:pPr algn="ctr" fontAlgn="ctr">
+                        <a:buNone/>
+                      </a:pPr>
+                      <a:r>
+                        <a:rPr lang="en" sz="1000" u="none" strike="noStrike" dirty="0">
+                          <a:effectLst/>
+                          <a:hlinkClick r:id="rId11"/>
+                        </a:rPr>
+                        <a:t>https://</a:t>
+                      </a:r>
+                      <a:r>
+                        <a:rPr lang="en" sz="1000" u="none" strike="noStrike" dirty="0" err="1">
+                          <a:effectLst/>
+                          <a:hlinkClick r:id="rId11"/>
+                        </a:rPr>
+                        <a:t>github.com</a:t>
+                      </a:r>
+                      <a:r>
+                        <a:rPr lang="en" sz="1000" u="none" strike="noStrike" dirty="0">
+                          <a:effectLst/>
+                          <a:hlinkClick r:id="rId11"/>
+                        </a:rPr>
+                        <a:t>/lcx-0504/Web-Service-and-Data-CW1/tree/main/docs/</a:t>
+                      </a:r>
+                      <a:r>
+                        <a:rPr lang="en" sz="1000" u="none" strike="noStrike" dirty="0" err="1">
+                          <a:effectLst/>
+                          <a:hlinkClick r:id="rId11"/>
+                        </a:rPr>
+                        <a:t>genai</a:t>
+                      </a:r>
+                      <a:r>
+                        <a:rPr lang="en" sz="1000" u="none" strike="noStrike" dirty="0">
+                          <a:effectLst/>
+                          <a:hlinkClick r:id="rId11"/>
+                        </a:rPr>
+                        <a:t>-logs</a:t>
+                      </a:r>
+                      <a:endParaRPr lang="en" sz="1000" b="0" i="0" u="none" strike="noStrike" dirty="0">
+                        <a:solidFill>
+                          <a:srgbClr val="000000"/>
+                        </a:solidFill>
+                        <a:effectLst/>
+                        <a:latin typeface="等线" panose="02010600030101010101" pitchFamily="2" charset="-122"/>
+                        <a:ea typeface="等线" panose="02010600030101010101" pitchFamily="2" charset="-122"/>
+                      </a:endParaRPr>
+                    </a:p>
+                  </a:txBody>
+                  <a:tcPr marL="4747" marR="4747" marT="4747" marB="0" anchor="ctr"/>
+                </a:tc>
+                <a:extLst>
+                  <a:ext uri="{0D108BD9-81ED-4DB2-BD59-A6C34878D82A}">
+                    <a16:rowId xmlns:a16="http://schemas.microsoft.com/office/drawing/2014/main" val="2315728657"/>
+                  </a:ext>
+                </a:extLst>
+              </a:tr>
+              <a:tr h="311779">
+                <a:tc>
+                  <a:txBody>
+                    <a:bodyPr/>
+                    <a:lstStyle/>
+                    <a:p>
+                      <a:pPr algn="ctr" fontAlgn="ctr">
+                        <a:buNone/>
+                      </a:pPr>
+                      <a:r>
+                        <a:rPr lang="en" sz="1000" u="none" strike="noStrike" dirty="0">
+                          <a:effectLst/>
+                        </a:rPr>
+                        <a:t>MCP Server (16 tools)</a:t>
+                      </a:r>
+                      <a:endParaRPr lang="en" sz="1000" b="0" i="0" u="none" strike="noStrike" dirty="0">
+                        <a:solidFill>
+                          <a:srgbClr val="000000"/>
+                        </a:solidFill>
+                        <a:effectLst/>
+                        <a:latin typeface="等线" panose="02010600030101010101" pitchFamily="2" charset="-122"/>
+                        <a:ea typeface="等线" panose="02010600030101010101" pitchFamily="2" charset="-122"/>
+                      </a:endParaRPr>
+                    </a:p>
+                  </a:txBody>
+                  <a:tcPr marL="4747" marR="4747" marT="4747" marB="0" anchor="ctr"/>
+                </a:tc>
+                <a:tc>
+                  <a:txBody>
+                    <a:bodyPr/>
+                    <a:lstStyle/>
+                    <a:p>
+                      <a:pPr algn="ctr" fontAlgn="ctr">
+                        <a:buNone/>
+                      </a:pPr>
+                      <a:r>
+                        <a:rPr lang="en" sz="1000" u="none" strike="noStrike" dirty="0">
+                          <a:effectLst/>
+                          <a:hlinkClick r:id="rId12"/>
+                        </a:rPr>
+                        <a:t>https://</a:t>
+                      </a:r>
+                      <a:r>
+                        <a:rPr lang="en" sz="1000" u="none" strike="noStrike" dirty="0" err="1">
+                          <a:effectLst/>
+                          <a:hlinkClick r:id="rId12"/>
+                        </a:rPr>
+                        <a:t>github.com</a:t>
+                      </a:r>
+                      <a:r>
+                        <a:rPr lang="en" sz="1000" u="none" strike="noStrike" dirty="0">
+                          <a:effectLst/>
+                          <a:hlinkClick r:id="rId12"/>
+                        </a:rPr>
+                        <a:t>/lcx-0504/Web-Service-and-Data-CW1/blob/main/</a:t>
+                      </a:r>
+                      <a:r>
+                        <a:rPr lang="en" sz="1000" u="none" strike="noStrike" dirty="0" err="1">
+                          <a:effectLst/>
+                          <a:hlinkClick r:id="rId12"/>
+                        </a:rPr>
+                        <a:t>mcp_server</a:t>
+                      </a:r>
+                      <a:r>
+                        <a:rPr lang="en" sz="1000" u="none" strike="noStrike" dirty="0">
+                          <a:effectLst/>
+                          <a:hlinkClick r:id="rId12"/>
+                        </a:rPr>
+                        <a:t>/</a:t>
+                      </a:r>
+                      <a:r>
+                        <a:rPr lang="en" sz="1000" u="none" strike="noStrike" dirty="0" err="1">
+                          <a:effectLst/>
+                          <a:hlinkClick r:id="rId12"/>
+                        </a:rPr>
+                        <a:t>server.py</a:t>
+                      </a:r>
+                      <a:endParaRPr lang="en" sz="1000" b="0" i="0" u="none" strike="noStrike" dirty="0">
+                        <a:solidFill>
+                          <a:srgbClr val="000000"/>
+                        </a:solidFill>
+                        <a:effectLst/>
+                        <a:latin typeface="等线" panose="02010600030101010101" pitchFamily="2" charset="-122"/>
+                        <a:ea typeface="等线" panose="02010600030101010101" pitchFamily="2" charset="-122"/>
+                      </a:endParaRPr>
+                    </a:p>
+                  </a:txBody>
+                  <a:tcPr marL="4747" marR="4747" marT="4747" marB="0" anchor="ctr"/>
+                </a:tc>
+                <a:extLst>
+                  <a:ext uri="{0D108BD9-81ED-4DB2-BD59-A6C34878D82A}">
+                    <a16:rowId xmlns:a16="http://schemas.microsoft.com/office/drawing/2014/main" val="889332172"/>
+                  </a:ext>
+                </a:extLst>
+              </a:tr>
+              <a:tr h="311779">
+                <a:tc>
+                  <a:txBody>
+                    <a:bodyPr/>
+                    <a:lstStyle/>
+                    <a:p>
+                      <a:pPr algn="ctr" fontAlgn="ctr">
+                        <a:buNone/>
+                      </a:pPr>
+                      <a:r>
+                        <a:rPr lang="en" sz="1000" u="none" strike="noStrike" dirty="0">
+                          <a:effectLst/>
+                        </a:rPr>
+                        <a:t>MCP Demo Video</a:t>
+                      </a:r>
+                      <a:endParaRPr lang="en" sz="1000" b="0" i="0" u="none" strike="noStrike" dirty="0">
+                        <a:solidFill>
+                          <a:srgbClr val="000000"/>
+                        </a:solidFill>
+                        <a:effectLst/>
+                        <a:latin typeface="等线" panose="02010600030101010101" pitchFamily="2" charset="-122"/>
+                        <a:ea typeface="等线" panose="02010600030101010101" pitchFamily="2" charset="-122"/>
+                      </a:endParaRPr>
+                    </a:p>
+                  </a:txBody>
+                  <a:tcPr marL="4747" marR="4747" marT="4747" marB="0" anchor="ctr"/>
+                </a:tc>
+                <a:tc>
+                  <a:txBody>
+                    <a:bodyPr/>
+                    <a:lstStyle/>
+                    <a:p>
+                      <a:pPr algn="ctr" fontAlgn="ctr">
+                        <a:buNone/>
+                      </a:pPr>
+                      <a:r>
+                        <a:rPr lang="en-US" sz="1000" u="none" strike="noStrike" dirty="0">
+                          <a:effectLst/>
+                        </a:rPr>
+                        <a:t>Multiple Links Provided in README: </a:t>
+                      </a:r>
+                      <a:r>
+                        <a:rPr lang="en-US" sz="1000" u="none" strike="noStrike" dirty="0">
+                          <a:effectLst/>
+                          <a:hlinkClick r:id="rId13"/>
+                        </a:rPr>
+                        <a:t>https://github.com/lcx-0504/Web-Service-and-Data-CW1/tree/main?tab=readme-ov-file#mcp-demo-video</a:t>
+                      </a:r>
+                      <a:endParaRPr lang="en" sz="1000" b="0" i="0" u="none" strike="noStrike" dirty="0">
+                        <a:solidFill>
+                          <a:srgbClr val="000000"/>
+                        </a:solidFill>
+                        <a:effectLst/>
+                        <a:latin typeface="等线" panose="02010600030101010101" pitchFamily="2" charset="-122"/>
+                        <a:ea typeface="等线" panose="02010600030101010101" pitchFamily="2" charset="-122"/>
+                      </a:endParaRPr>
+                    </a:p>
+                  </a:txBody>
+                  <a:tcPr marL="4747" marR="4747" marT="4747" marB="0" anchor="ctr"/>
+                </a:tc>
+                <a:extLst>
+                  <a:ext uri="{0D108BD9-81ED-4DB2-BD59-A6C34878D82A}">
+                    <a16:rowId xmlns:a16="http://schemas.microsoft.com/office/drawing/2014/main" val="1286136591"/>
+                  </a:ext>
+                </a:extLst>
+              </a:tr>
+              <a:tr h="311779">
+                <a:tc>
+                  <a:txBody>
+                    <a:bodyPr/>
+                    <a:lstStyle/>
+                    <a:p>
+                      <a:pPr algn="ctr" fontAlgn="ctr">
+                        <a:buNone/>
+                      </a:pPr>
+                      <a:r>
+                        <a:rPr lang="en" sz="1000" u="none" strike="noStrike" dirty="0">
+                          <a:effectLst/>
+                        </a:rPr>
+                        <a:t>Integration Tests</a:t>
+                      </a:r>
+                      <a:endParaRPr lang="en" sz="1000" b="0" i="0" u="none" strike="noStrike" dirty="0">
+                        <a:solidFill>
+                          <a:srgbClr val="000000"/>
+                        </a:solidFill>
+                        <a:effectLst/>
+                        <a:latin typeface="等线" panose="02010600030101010101" pitchFamily="2" charset="-122"/>
+                        <a:ea typeface="等线" panose="02010600030101010101" pitchFamily="2" charset="-122"/>
+                      </a:endParaRPr>
+                    </a:p>
+                  </a:txBody>
+                  <a:tcPr marL="4747" marR="4747" marT="4747" marB="0" anchor="ctr"/>
+                </a:tc>
+                <a:tc>
+                  <a:txBody>
+                    <a:bodyPr/>
+                    <a:lstStyle/>
+                    <a:p>
+                      <a:pPr algn="ctr" fontAlgn="ctr">
+                        <a:buNone/>
+                      </a:pPr>
+                      <a:r>
+                        <a:rPr lang="en" sz="1000" u="none" strike="noStrike" dirty="0">
+                          <a:effectLst/>
+                        </a:rPr>
+                        <a:t>Test Script: </a:t>
+                      </a:r>
+                      <a:r>
+                        <a:rPr lang="en" sz="1000" u="none" strike="noStrike" dirty="0">
+                          <a:effectLst/>
+                          <a:hlinkClick r:id="rId14"/>
+                        </a:rPr>
+                        <a:t>https://github.com/lcx-0504/Web-Service-and-Data-CW1/blob/main/backend/tests/test_api.py</a:t>
+                      </a:r>
+                      <a:endParaRPr lang="en" sz="1000" u="none" strike="noStrike" dirty="0">
+                        <a:effectLst/>
+                      </a:endParaRPr>
+                    </a:p>
+                    <a:p>
+                      <a:pPr algn="ctr" fontAlgn="ctr">
+                        <a:buNone/>
+                      </a:pPr>
+                      <a:r>
+                        <a:rPr lang="en" altLang="zh-CN" sz="1000" u="none" strike="noStrike" dirty="0">
+                          <a:effectLst/>
+                        </a:rPr>
+                        <a:t>Test Log: </a:t>
+                      </a:r>
+                      <a:r>
+                        <a:rPr lang="en" altLang="zh-CN" sz="1000" u="none" strike="noStrike" dirty="0">
+                          <a:effectLst/>
+                          <a:hlinkClick r:id="rId15"/>
+                        </a:rPr>
+                        <a:t>https://</a:t>
+                      </a:r>
+                      <a:r>
+                        <a:rPr lang="en" altLang="zh-CN" sz="1000" u="none" strike="noStrike" dirty="0" err="1">
+                          <a:effectLst/>
+                          <a:hlinkClick r:id="rId15"/>
+                        </a:rPr>
+                        <a:t>github.com</a:t>
+                      </a:r>
+                      <a:r>
+                        <a:rPr lang="en" altLang="zh-CN" sz="1000" u="none" strike="noStrike" dirty="0">
+                          <a:effectLst/>
+                          <a:hlinkClick r:id="rId15"/>
+                        </a:rPr>
+                        <a:t>/lcx-0504/Web-Service-and-Data-CW1/blob/main/docs/test-</a:t>
+                      </a:r>
+                      <a:r>
+                        <a:rPr lang="en" altLang="zh-CN" sz="1000" u="none" strike="noStrike" dirty="0" err="1">
+                          <a:effectLst/>
+                          <a:hlinkClick r:id="rId15"/>
+                        </a:rPr>
+                        <a:t>results.txt</a:t>
+                      </a:r>
+                      <a:r>
+                        <a:rPr lang="en" altLang="zh-CN" sz="1000" u="none" strike="noStrike" dirty="0">
+                          <a:effectLst/>
+                          <a:hlinkClick r:id="rId15"/>
+                        </a:rPr>
+                        <a:t> </a:t>
+                      </a:r>
+                      <a:endParaRPr lang="en" sz="1000" b="0" i="0" u="none" strike="noStrike" dirty="0">
+                        <a:solidFill>
+                          <a:srgbClr val="000000"/>
+                        </a:solidFill>
+                        <a:effectLst/>
+                        <a:latin typeface="等线" panose="02010600030101010101" pitchFamily="2" charset="-122"/>
+                        <a:ea typeface="等线" panose="02010600030101010101" pitchFamily="2" charset="-122"/>
+                      </a:endParaRPr>
+                    </a:p>
+                  </a:txBody>
+                  <a:tcPr marL="4747" marR="4747" marT="4747" marB="0" anchor="ctr"/>
+                </a:tc>
+                <a:extLst>
+                  <a:ext uri="{0D108BD9-81ED-4DB2-BD59-A6C34878D82A}">
+                    <a16:rowId xmlns:a16="http://schemas.microsoft.com/office/drawing/2014/main" val="2931861457"/>
+                  </a:ext>
+                </a:extLst>
+              </a:tr>
+            </a:tbl>
+          </a:graphicData>
+        </a:graphic>
+      </p:graphicFrame>
     </p:spTree>
+    <p:extLst>
+      <p:ext uri="{BB962C8B-B14F-4D97-AF65-F5344CB8AC3E}">
+        <p14:creationId xmlns:p14="http://schemas.microsoft.com/office/powerpoint/2010/main" val="3923434233"/>
+      </p:ext>
+    </p:extLst>
   </p:cSld>
   <p:clrMapOvr>
     <a:masterClrMapping/>

</xml_diff>

<commit_message>
fix: unify search ranking to 2-level, MCP default to PythonAnywhere
- Fix search ranking description: 3-level → 2-level (starts-with > contains)
  across technical report, API docs, presentation, and GenAI logs
- MCP config: default to PythonAnywhere, support NUTRITRACK_API_URL env var
- README: add online MCP usage instructions with env var override for local
</commit_message>
<xml_diff>
--- a/docs/presentation.pptx
+++ b/docs/presentation.pptx
@@ -4186,7 +4186,7 @@
                 <a:ea typeface="Arial" pitchFamily="34" charset="-122"/>
                 <a:cs typeface="Arial" pitchFamily="34" charset="-120"/>
               </a:rPr>
-              <a:t>3-level relevance ranking:</a:t>
+              <a:t>2-level relevance ranking:</a:t>
             </a:r>
             <a:endParaRPr lang="en-US" sz="1600" dirty="0"/>
           </a:p>
@@ -4206,7 +4206,7 @@
                 <a:ea typeface="Arial" pitchFamily="34" charset="-122"/>
                 <a:cs typeface="Arial" pitchFamily="34" charset="-120"/>
               </a:rPr>
-              <a:t>starts-with &gt; word-boundary &gt; substring</a:t>
+              <a:t>starts-with &gt; contains</a:t>
             </a:r>
             <a:endParaRPr lang="en-US" sz="1600" dirty="0"/>
           </a:p>

</xml_diff>

<commit_message>
docs: fix doc-code inconsistencies, complete pyproject.toml deps, update PDFs
- api-documentation.md: POST/PUT meals 404→400 for food_id, add PUT errors,
  quantity/height/weight ranges corrected to >0, weight example 350, remove phantom warning
- technical-report.md: 130kg→300/350kg, test_integration→test_api, httpx→requests, --base-url
- pyproject.toml: add email-validator, python-multipart, bcrypt<5.0; fix dev deps
- requirements.txt: add alembic
- README.md: remove redundant pip install, add MCP deps, fix categories 28→25,
  fix test refs, improve Quick Start flow
</commit_message>
<xml_diff>
--- a/docs/presentation.pptx
+++ b/docs/presentation.pptx
@@ -4376,7 +4376,29 @@
                 <a:ea typeface="Arial" pitchFamily="34" charset="-122"/>
                 <a:cs typeface="Arial" pitchFamily="34" charset="-120"/>
               </a:rPr>
-              <a:t>"Weight 130 kg is unusually high. Please verify."</a:t>
+              <a:t>"Weight </a:t>
+            </a:r>
+            <a:r>
+              <a:rPr lang="en-US" altLang="zh-CN" sz="1600" dirty="0">
+                <a:solidFill>
+                  <a:srgbClr val="2D2D2D"/>
+                </a:solidFill>
+                <a:latin typeface="Arial" pitchFamily="34" charset="0"/>
+                <a:ea typeface="Arial" pitchFamily="34" charset="-122"/>
+                <a:cs typeface="Arial" pitchFamily="34" charset="-120"/>
+              </a:rPr>
+              <a:t>350</a:t>
+            </a:r>
+            <a:r>
+              <a:rPr lang="en-US" sz="1600" dirty="0">
+                <a:solidFill>
+                  <a:srgbClr val="2D2D2D"/>
+                </a:solidFill>
+                <a:latin typeface="Arial" pitchFamily="34" charset="0"/>
+                <a:ea typeface="Arial" pitchFamily="34" charset="-122"/>
+                <a:cs typeface="Arial" pitchFamily="34" charset="-120"/>
+              </a:rPr>
+              <a:t> kg is unusually high. Please verify."</a:t>
             </a:r>
             <a:endParaRPr lang="en-US" sz="1600" dirty="0"/>
           </a:p>

</xml_diff>